<commit_message>
docs: switch presentation to Comfortaa font
</commit_message>
<xml_diff>
--- a/specs-format-presentation.pptx
+++ b/specs-format-presentation.pptx
@@ -1649,13 +1649,15 @@
                 <a:solidFill>
                   <a:srgbClr val="FFFFFF"/>
                 </a:solidFill>
-                <a:latin typeface="Georgia" pitchFamily="34" charset="0"/>
+                <a:latin typeface="Comfortaa" pitchFamily="2" charset="0"/>
                 <a:ea typeface="Georgia" pitchFamily="34" charset="-122"/>
                 <a:cs typeface="Georgia" pitchFamily="34" charset="-120"/>
               </a:rPr>
               <a:t>Specs as Code</a:t>
             </a:r>
-            <a:endParaRPr lang="en-US" sz="5600" dirty="0"/>
+            <a:endParaRPr lang="en-US" sz="5600" dirty="0">
+              <a:latin typeface="Comfortaa Medium" pitchFamily="2" charset="0"/>
+            </a:endParaRPr>
           </a:p>
         </p:txBody>
       </p:sp>
@@ -1731,7 +1733,7 @@
                 <a:ea typeface="Calibri" pitchFamily="34" charset="-122"/>
                 <a:cs typeface="Calibri" pitchFamily="34" charset="-120"/>
               </a:rPr>
-              <a:t>Carlo  ·  v0.1 draft  ·  internal</a:t>
+              <a:t>Carlo  ·  v0.1 draft</a:t>
             </a:r>
             <a:endParaRPr lang="en-US" sz="1200" dirty="0"/>
           </a:p>
@@ -1799,13 +1801,15 @@
                 <a:solidFill>
                   <a:srgbClr val="1A1A1A"/>
                 </a:solidFill>
-                <a:latin typeface="Georgia" pitchFamily="34" charset="0"/>
+                <a:latin typeface="Comfortaa" pitchFamily="2" charset="0"/>
                 <a:ea typeface="Georgia" pitchFamily="34" charset="-122"/>
                 <a:cs typeface="Georgia" pitchFamily="34" charset="-120"/>
               </a:rPr>
               <a:t>Why not just plain Markdown?</a:t>
             </a:r>
-            <a:endParaRPr lang="en-US" sz="3000" dirty="0"/>
+            <a:endParaRPr lang="en-US" sz="3000" dirty="0">
+              <a:latin typeface="Comfortaa Medium" pitchFamily="2" charset="0"/>
+            </a:endParaRPr>
           </a:p>
         </p:txBody>
       </p:sp>
@@ -3353,13 +3357,15 @@
                 <a:solidFill>
                   <a:srgbClr val="1A1A1A"/>
                 </a:solidFill>
-                <a:latin typeface="Georgia" pitchFamily="34" charset="0"/>
+                <a:latin typeface="Comfortaa" pitchFamily="2" charset="0"/>
                 <a:ea typeface="Georgia" pitchFamily="34" charset="-122"/>
                 <a:cs typeface="Georgia" pitchFamily="34" charset="-120"/>
               </a:rPr>
               <a:t>Why not YAML / JSON Schema only?</a:t>
             </a:r>
-            <a:endParaRPr lang="en-US" sz="3000" dirty="0"/>
+            <a:endParaRPr lang="en-US" sz="3000" dirty="0">
+              <a:latin typeface="Comfortaa Medium" pitchFamily="2" charset="0"/>
+            </a:endParaRPr>
           </a:p>
         </p:txBody>
       </p:sp>
@@ -3458,13 +3464,15 @@
                 <a:solidFill>
                   <a:srgbClr val="1A1A1A"/>
                 </a:solidFill>
-                <a:latin typeface="Georgia" pitchFamily="34" charset="0"/>
+                <a:latin typeface="Comfortaa" pitchFamily="2" charset="0"/>
                 <a:ea typeface="Georgia" pitchFamily="34" charset="-122"/>
                 <a:cs typeface="Georgia" pitchFamily="34" charset="-120"/>
               </a:rPr>
               <a:t>Specs are mostly intent</a:t>
             </a:r>
-            <a:endParaRPr lang="en-US" sz="1600" dirty="0"/>
+            <a:endParaRPr lang="en-US" sz="1600" dirty="0">
+              <a:latin typeface="Comfortaa Medium" pitchFamily="2" charset="0"/>
+            </a:endParaRPr>
           </a:p>
         </p:txBody>
       </p:sp>
@@ -3563,13 +3571,15 @@
                 <a:solidFill>
                   <a:srgbClr val="1A1A1A"/>
                 </a:solidFill>
-                <a:latin typeface="Georgia" pitchFamily="34" charset="0"/>
+                <a:latin typeface="Comfortaa" pitchFamily="2" charset="0"/>
                 <a:ea typeface="Georgia" pitchFamily="34" charset="-122"/>
                 <a:cs typeface="Georgia" pitchFamily="34" charset="-120"/>
               </a:rPr>
               <a:t>Reviewability</a:t>
             </a:r>
-            <a:endParaRPr lang="en-US" sz="1600" dirty="0"/>
+            <a:endParaRPr lang="en-US" sz="1600" dirty="0">
+              <a:latin typeface="Comfortaa Medium" pitchFamily="2" charset="0"/>
+            </a:endParaRPr>
           </a:p>
         </p:txBody>
       </p:sp>
@@ -3668,13 +3678,15 @@
                 <a:solidFill>
                   <a:srgbClr val="1A1A1A"/>
                 </a:solidFill>
-                <a:latin typeface="Georgia" pitchFamily="34" charset="0"/>
+                <a:latin typeface="Comfortaa" pitchFamily="2" charset="0"/>
                 <a:ea typeface="Georgia" pitchFamily="34" charset="-122"/>
                 <a:cs typeface="Georgia" pitchFamily="34" charset="-120"/>
               </a:rPr>
               <a:t>Editor support</a:t>
             </a:r>
-            <a:endParaRPr lang="en-US" sz="1600" dirty="0"/>
+            <a:endParaRPr lang="en-US" sz="1600" dirty="0">
+              <a:latin typeface="Comfortaa Medium" pitchFamily="2" charset="0"/>
+            </a:endParaRPr>
           </a:p>
         </p:txBody>
       </p:sp>
@@ -3773,13 +3785,15 @@
                 <a:solidFill>
                   <a:srgbClr val="1A1A1A"/>
                 </a:solidFill>
-                <a:latin typeface="Georgia" pitchFamily="34" charset="0"/>
+                <a:latin typeface="Comfortaa" pitchFamily="2" charset="0"/>
                 <a:ea typeface="Georgia" pitchFamily="34" charset="-122"/>
                 <a:cs typeface="Georgia" pitchFamily="34" charset="-120"/>
               </a:rPr>
               <a:t>Hybrid wins</a:t>
             </a:r>
-            <a:endParaRPr lang="en-US" sz="1600" dirty="0"/>
+            <a:endParaRPr lang="en-US" sz="1600" dirty="0">
+              <a:latin typeface="Comfortaa Medium" pitchFamily="2" charset="0"/>
+            </a:endParaRPr>
           </a:p>
         </p:txBody>
       </p:sp>
@@ -3989,42 +4003,190 @@
                 <a:solidFill>
                   <a:srgbClr val="FFFFFF"/>
                 </a:solidFill>
+                <a:latin typeface="Comfortaa" pitchFamily="2" charset="0"/>
+                <a:ea typeface="Georgia" pitchFamily="34" charset="-122"/>
+                <a:cs typeface="Georgia" pitchFamily="34" charset="-120"/>
+              </a:rPr>
+              <a:t>Adoption path</a:t>
+            </a:r>
+            <a:endParaRPr lang="en-US" sz="3600" dirty="0">
+              <a:latin typeface="Comfortaa Medium" pitchFamily="2" charset="0"/>
+            </a:endParaRPr>
+          </a:p>
+        </p:txBody>
+      </p:sp>
+      <p:sp>
+        <p:nvSpPr>
+          <p:cNvPr id="4" name="Text 2"/>
+          <p:cNvSpPr/>
+          <p:nvPr/>
+        </p:nvSpPr>
+        <p:spPr>
+          <a:xfrm>
+            <a:off x="640080" y="1691640"/>
+            <a:ext cx="10515600" cy="411480"/>
+          </a:xfrm>
+          <a:prstGeom prst="rect">
+            <a:avLst/>
+          </a:prstGeom>
+          <a:noFill/>
+          <a:ln/>
+        </p:spPr>
+        <p:txBody>
+          <a:bodyPr wrap="square" lIns="0" tIns="0" rIns="0" bIns="0" rtlCol="0" anchor="ctr"/>
+          <a:lstStyle/>
+          <a:p>
+            <a:pPr marL="0" indent="0">
+              <a:buNone/>
+            </a:pPr>
+            <a:r>
+              <a:rPr lang="en-US" sz="1600" i="1" dirty="0">
+                <a:solidFill>
+                  <a:srgbClr val="CFCFCF"/>
+                </a:solidFill>
+                <a:latin typeface="Calibri" pitchFamily="34" charset="0"/>
+                <a:ea typeface="Calibri" pitchFamily="34" charset="-122"/>
+                <a:cs typeface="Calibri" pitchFamily="34" charset="-120"/>
+              </a:rPr>
+              <a:t>Start small. Add structure where it earns its keep.</a:t>
+            </a:r>
+            <a:endParaRPr lang="en-US" sz="1600" dirty="0"/>
+          </a:p>
+        </p:txBody>
+      </p:sp>
+      <p:sp>
+        <p:nvSpPr>
+          <p:cNvPr id="5" name="Shape 3"/>
+          <p:cNvSpPr/>
+          <p:nvPr/>
+        </p:nvSpPr>
+        <p:spPr>
+          <a:xfrm>
+            <a:off x="777240" y="2514600"/>
+            <a:ext cx="502920" cy="502920"/>
+          </a:xfrm>
+          <a:prstGeom prst="ellipse">
+            <a:avLst/>
+          </a:prstGeom>
+          <a:solidFill>
+            <a:srgbClr val="028090"/>
+          </a:solidFill>
+          <a:ln/>
+        </p:spPr>
+        <p:txBody>
+          <a:bodyPr/>
+          <a:lstStyle/>
+          <a:p>
+            <a:endParaRPr lang="en-US"/>
+          </a:p>
+        </p:txBody>
+      </p:sp>
+      <p:sp>
+        <p:nvSpPr>
+          <p:cNvPr id="6" name="Text 4"/>
+          <p:cNvSpPr/>
+          <p:nvPr/>
+        </p:nvSpPr>
+        <p:spPr>
+          <a:xfrm>
+            <a:off x="777240" y="2514600"/>
+            <a:ext cx="502920" cy="502920"/>
+          </a:xfrm>
+          <a:prstGeom prst="rect">
+            <a:avLst/>
+          </a:prstGeom>
+          <a:noFill/>
+          <a:ln/>
+        </p:spPr>
+        <p:txBody>
+          <a:bodyPr wrap="square" lIns="0" tIns="0" rIns="0" bIns="0" rtlCol="0" anchor="ctr"/>
+          <a:lstStyle/>
+          <a:p>
+            <a:pPr marL="0" indent="0" algn="ctr">
+              <a:buNone/>
+            </a:pPr>
+            <a:r>
+              <a:rPr lang="en-US" sz="1800" b="1" dirty="0">
+                <a:solidFill>
+                  <a:srgbClr val="FFFFFF"/>
+                </a:solidFill>
                 <a:latin typeface="Georgia" pitchFamily="34" charset="0"/>
                 <a:ea typeface="Georgia" pitchFamily="34" charset="-122"/>
                 <a:cs typeface="Georgia" pitchFamily="34" charset="-120"/>
               </a:rPr>
-              <a:t>Adoption path</a:t>
-            </a:r>
-            <a:endParaRPr lang="en-US" sz="3600" dirty="0"/>
-          </a:p>
-        </p:txBody>
-      </p:sp>
-      <p:sp>
-        <p:nvSpPr>
-          <p:cNvPr id="4" name="Text 2"/>
-          <p:cNvSpPr/>
-          <p:nvPr/>
-        </p:nvSpPr>
-        <p:spPr>
-          <a:xfrm>
-            <a:off x="640080" y="1691640"/>
-            <a:ext cx="10515600" cy="411480"/>
-          </a:xfrm>
-          <a:prstGeom prst="rect">
-            <a:avLst/>
-          </a:prstGeom>
-          <a:noFill/>
-          <a:ln/>
-        </p:spPr>
-        <p:txBody>
-          <a:bodyPr wrap="square" lIns="0" tIns="0" rIns="0" bIns="0" rtlCol="0" anchor="ctr"/>
-          <a:lstStyle/>
-          <a:p>
-            <a:pPr marL="0" indent="0">
-              <a:buNone/>
-            </a:pPr>
-            <a:r>
-              <a:rPr lang="en-US" sz="1600" i="1" dirty="0">
+              <a:t>1</a:t>
+            </a:r>
+            <a:endParaRPr lang="en-US" sz="1800" dirty="0"/>
+          </a:p>
+        </p:txBody>
+      </p:sp>
+      <p:sp>
+        <p:nvSpPr>
+          <p:cNvPr id="7" name="Text 5"/>
+          <p:cNvSpPr/>
+          <p:nvPr/>
+        </p:nvSpPr>
+        <p:spPr>
+          <a:xfrm>
+            <a:off x="1417320" y="2569464"/>
+            <a:ext cx="3657600" cy="365760"/>
+          </a:xfrm>
+          <a:prstGeom prst="rect">
+            <a:avLst/>
+          </a:prstGeom>
+          <a:noFill/>
+          <a:ln/>
+        </p:spPr>
+        <p:txBody>
+          <a:bodyPr wrap="square" lIns="0" tIns="0" rIns="0" bIns="0" rtlCol="0" anchor="ctr"/>
+          <a:lstStyle/>
+          <a:p>
+            <a:pPr marL="0" indent="0">
+              <a:buNone/>
+            </a:pPr>
+            <a:r>
+              <a:rPr lang="en-US" sz="1600" b="1" dirty="0">
+                <a:solidFill>
+                  <a:srgbClr val="FFFFFF"/>
+                </a:solidFill>
+                <a:latin typeface="Comfortaa" pitchFamily="2" charset="0"/>
+                <a:ea typeface="Georgia" pitchFamily="34" charset="-122"/>
+                <a:cs typeface="Georgia" pitchFamily="34" charset="-120"/>
+              </a:rPr>
+              <a:t>Pick one feature</a:t>
+            </a:r>
+            <a:endParaRPr lang="en-US" sz="1600" dirty="0">
+              <a:latin typeface="Comfortaa Medium" pitchFamily="2" charset="0"/>
+            </a:endParaRPr>
+          </a:p>
+        </p:txBody>
+      </p:sp>
+      <p:sp>
+        <p:nvSpPr>
+          <p:cNvPr id="8" name="Text 6"/>
+          <p:cNvSpPr/>
+          <p:nvPr/>
+        </p:nvSpPr>
+        <p:spPr>
+          <a:xfrm>
+            <a:off x="5212080" y="2514600"/>
+            <a:ext cx="6400800" cy="502920"/>
+          </a:xfrm>
+          <a:prstGeom prst="rect">
+            <a:avLst/>
+          </a:prstGeom>
+          <a:noFill/>
+          <a:ln/>
+        </p:spPr>
+        <p:txBody>
+          <a:bodyPr wrap="square" lIns="0" tIns="0" rIns="0" bIns="0" rtlCol="0" anchor="ctr"/>
+          <a:lstStyle/>
+          <a:p>
+            <a:pPr marL="0" indent="0">
+              <a:buNone/>
+            </a:pPr>
+            <a:r>
+              <a:rPr lang="en-US" sz="1200" dirty="0">
                 <a:solidFill>
                   <a:srgbClr val="CFCFCF"/>
                 </a:solidFill>
@@ -4032,21 +4194,21 @@
                 <a:ea typeface="Calibri" pitchFamily="34" charset="-122"/>
                 <a:cs typeface="Calibri" pitchFamily="34" charset="-120"/>
               </a:rPr>
-              <a:t>Start small. Add structure where it earns its keep.</a:t>
-            </a:r>
-            <a:endParaRPr lang="en-US" sz="1600" dirty="0"/>
-          </a:p>
-        </p:txBody>
-      </p:sp>
-      <p:sp>
-        <p:nvSpPr>
-          <p:cNvPr id="5" name="Shape 3"/>
-          <p:cNvSpPr/>
-          <p:nvPr/>
-        </p:nvSpPr>
-        <p:spPr>
-          <a:xfrm>
-            <a:off x="777240" y="2514600"/>
+              <a:t>Convert its existing notes to .spec.md. No tooling required to start.</a:t>
+            </a:r>
+            <a:endParaRPr lang="en-US" sz="1200" dirty="0"/>
+          </a:p>
+        </p:txBody>
+      </p:sp>
+      <p:sp>
+        <p:nvSpPr>
+          <p:cNvPr id="9" name="Shape 7"/>
+          <p:cNvSpPr/>
+          <p:nvPr/>
+        </p:nvSpPr>
+        <p:spPr>
+          <a:xfrm>
+            <a:off x="777240" y="3227832"/>
             <a:ext cx="502920" cy="502920"/>
           </a:xfrm>
           <a:prstGeom prst="ellipse">
@@ -4067,13 +4229,13 @@
       </p:sp>
       <p:sp>
         <p:nvSpPr>
-          <p:cNvPr id="6" name="Text 4"/>
-          <p:cNvSpPr/>
-          <p:nvPr/>
-        </p:nvSpPr>
-        <p:spPr>
-          <a:xfrm>
-            <a:off x="777240" y="2514600"/>
+          <p:cNvPr id="10" name="Text 8"/>
+          <p:cNvSpPr/>
+          <p:nvPr/>
+        </p:nvSpPr>
+        <p:spPr>
+          <a:xfrm>
+            <a:off x="777240" y="3227832"/>
             <a:ext cx="502920" cy="502920"/>
           </a:xfrm>
           <a:prstGeom prst="rect">
@@ -4098,7 +4260,7 @@
                 <a:ea typeface="Georgia" pitchFamily="34" charset="-122"/>
                 <a:cs typeface="Georgia" pitchFamily="34" charset="-120"/>
               </a:rPr>
-              <a:t>1</a:t>
+              <a:t>2</a:t>
             </a:r>
             <a:endParaRPr lang="en-US" sz="1800" dirty="0"/>
           </a:p>
@@ -4106,13 +4268,13 @@
       </p:sp>
       <p:sp>
         <p:nvSpPr>
-          <p:cNvPr id="7" name="Text 5"/>
-          <p:cNvSpPr/>
-          <p:nvPr/>
-        </p:nvSpPr>
-        <p:spPr>
-          <a:xfrm>
-            <a:off x="1508760" y="2468880"/>
+          <p:cNvPr id="11" name="Text 9"/>
+          <p:cNvSpPr/>
+          <p:nvPr/>
+        </p:nvSpPr>
+        <p:spPr>
+          <a:xfrm>
+            <a:off x="1417320" y="3282696"/>
             <a:ext cx="3657600" cy="365760"/>
           </a:xfrm>
           <a:prstGeom prst="rect">
@@ -4130,6 +4292,113 @@
             </a:pPr>
             <a:r>
               <a:rPr lang="en-US" sz="1600" b="1" dirty="0">
+                <a:solidFill>
+                  <a:srgbClr val="FFFFFF"/>
+                </a:solidFill>
+                <a:latin typeface="Comfortaa" pitchFamily="2" charset="0"/>
+                <a:ea typeface="Georgia" pitchFamily="34" charset="-122"/>
+                <a:cs typeface="Georgia" pitchFamily="34" charset="-120"/>
+              </a:rPr>
+              <a:t>Add the linter</a:t>
+            </a:r>
+            <a:endParaRPr lang="en-US" sz="1600" dirty="0">
+              <a:latin typeface="Comfortaa Medium" pitchFamily="2" charset="0"/>
+            </a:endParaRPr>
+          </a:p>
+        </p:txBody>
+      </p:sp>
+      <p:sp>
+        <p:nvSpPr>
+          <p:cNvPr id="12" name="Text 10"/>
+          <p:cNvSpPr/>
+          <p:nvPr/>
+        </p:nvSpPr>
+        <p:spPr>
+          <a:xfrm>
+            <a:off x="5212080" y="3227832"/>
+            <a:ext cx="6400800" cy="502920"/>
+          </a:xfrm>
+          <a:prstGeom prst="rect">
+            <a:avLst/>
+          </a:prstGeom>
+          <a:noFill/>
+          <a:ln/>
+        </p:spPr>
+        <p:txBody>
+          <a:bodyPr wrap="square" lIns="0" tIns="0" rIns="0" bIns="0" rtlCol="0" anchor="ctr"/>
+          <a:lstStyle/>
+          <a:p>
+            <a:pPr marL="0" indent="0">
+              <a:buNone/>
+            </a:pPr>
+            <a:r>
+              <a:rPr lang="en-US" sz="1200" dirty="0">
+                <a:solidFill>
+                  <a:srgbClr val="CFCFCF"/>
+                </a:solidFill>
+                <a:latin typeface="Calibri" pitchFamily="34" charset="0"/>
+                <a:ea typeface="Calibri" pitchFamily="34" charset="-122"/>
+                <a:cs typeface="Calibri" pitchFamily="34" charset="-120"/>
+              </a:rPr>
+              <a:t>Wire `spec lint` into pre-commit. Errors stay manageable when the corpus is small.</a:t>
+            </a:r>
+            <a:endParaRPr lang="en-US" sz="1200" dirty="0"/>
+          </a:p>
+        </p:txBody>
+      </p:sp>
+      <p:sp>
+        <p:nvSpPr>
+          <p:cNvPr id="13" name="Shape 11"/>
+          <p:cNvSpPr/>
+          <p:nvPr/>
+        </p:nvSpPr>
+        <p:spPr>
+          <a:xfrm>
+            <a:off x="777240" y="3941064"/>
+            <a:ext cx="502920" cy="502920"/>
+          </a:xfrm>
+          <a:prstGeom prst="ellipse">
+            <a:avLst/>
+          </a:prstGeom>
+          <a:solidFill>
+            <a:srgbClr val="028090"/>
+          </a:solidFill>
+          <a:ln/>
+        </p:spPr>
+        <p:txBody>
+          <a:bodyPr/>
+          <a:lstStyle/>
+          <a:p>
+            <a:endParaRPr lang="en-US"/>
+          </a:p>
+        </p:txBody>
+      </p:sp>
+      <p:sp>
+        <p:nvSpPr>
+          <p:cNvPr id="14" name="Text 12"/>
+          <p:cNvSpPr/>
+          <p:nvPr/>
+        </p:nvSpPr>
+        <p:spPr>
+          <a:xfrm>
+            <a:off x="777240" y="3941064"/>
+            <a:ext cx="502920" cy="502920"/>
+          </a:xfrm>
+          <a:prstGeom prst="rect">
+            <a:avLst/>
+          </a:prstGeom>
+          <a:noFill/>
+          <a:ln/>
+        </p:spPr>
+        <p:txBody>
+          <a:bodyPr wrap="square" lIns="0" tIns="0" rIns="0" bIns="0" rtlCol="0" anchor="ctr"/>
+          <a:lstStyle/>
+          <a:p>
+            <a:pPr marL="0" indent="0" algn="ctr">
+              <a:buNone/>
+            </a:pPr>
+            <a:r>
+              <a:rPr lang="en-US" sz="1800" b="1" dirty="0">
                 <a:solidFill>
                   <a:srgbClr val="FFFFFF"/>
                 </a:solidFill>
@@ -4137,21 +4406,62 @@
                 <a:ea typeface="Georgia" pitchFamily="34" charset="-122"/>
                 <a:cs typeface="Georgia" pitchFamily="34" charset="-120"/>
               </a:rPr>
-              <a:t>Pick one feature</a:t>
-            </a:r>
-            <a:endParaRPr lang="en-US" sz="1600" dirty="0"/>
-          </a:p>
-        </p:txBody>
-      </p:sp>
-      <p:sp>
-        <p:nvSpPr>
-          <p:cNvPr id="8" name="Text 6"/>
-          <p:cNvSpPr/>
-          <p:nvPr/>
-        </p:nvSpPr>
-        <p:spPr>
-          <a:xfrm>
-            <a:off x="5212080" y="2514600"/>
+              <a:t>3</a:t>
+            </a:r>
+            <a:endParaRPr lang="en-US" sz="1800" dirty="0"/>
+          </a:p>
+        </p:txBody>
+      </p:sp>
+      <p:sp>
+        <p:nvSpPr>
+          <p:cNvPr id="15" name="Text 13"/>
+          <p:cNvSpPr/>
+          <p:nvPr/>
+        </p:nvSpPr>
+        <p:spPr>
+          <a:xfrm>
+            <a:off x="1417320" y="3995928"/>
+            <a:ext cx="3657600" cy="365760"/>
+          </a:xfrm>
+          <a:prstGeom prst="rect">
+            <a:avLst/>
+          </a:prstGeom>
+          <a:noFill/>
+          <a:ln/>
+        </p:spPr>
+        <p:txBody>
+          <a:bodyPr wrap="square" lIns="0" tIns="0" rIns="0" bIns="0" rtlCol="0" anchor="ctr"/>
+          <a:lstStyle/>
+          <a:p>
+            <a:pPr marL="0" indent="0">
+              <a:buNone/>
+            </a:pPr>
+            <a:r>
+              <a:rPr lang="en-US" sz="1600" b="1" dirty="0">
+                <a:solidFill>
+                  <a:srgbClr val="FFFFFF"/>
+                </a:solidFill>
+                <a:latin typeface="Comfortaa" pitchFamily="2" charset="0"/>
+                <a:ea typeface="Georgia" pitchFamily="34" charset="-122"/>
+                <a:cs typeface="Georgia" pitchFamily="34" charset="-120"/>
+              </a:rPr>
+              <a:t>Trailer commits</a:t>
+            </a:r>
+            <a:endParaRPr lang="en-US" sz="1600" dirty="0">
+              <a:latin typeface="Comfortaa Medium" pitchFamily="2" charset="0"/>
+            </a:endParaRPr>
+          </a:p>
+        </p:txBody>
+      </p:sp>
+      <p:sp>
+        <p:nvSpPr>
+          <p:cNvPr id="16" name="Text 14"/>
+          <p:cNvSpPr/>
+          <p:nvPr/>
+        </p:nvSpPr>
+        <p:spPr>
+          <a:xfrm>
+            <a:off x="5212080" y="3941064"/>
             <a:ext cx="6400800" cy="502920"/>
           </a:xfrm>
           <a:prstGeom prst="rect">
@@ -4176,7 +4486,7 @@
                 <a:ea typeface="Calibri" pitchFamily="34" charset="-122"/>
                 <a:cs typeface="Calibri" pitchFamily="34" charset="-120"/>
               </a:rPr>
-              <a:t>Convert its existing notes to .spec.md. No tooling required to start.</a:t>
+              <a:t>Start adding Spec-Ref to commit messages. History fills in over time.</a:t>
             </a:r>
             <a:endParaRPr lang="en-US" sz="1200" dirty="0"/>
           </a:p>
@@ -4184,13 +4494,13 @@
       </p:sp>
       <p:sp>
         <p:nvSpPr>
-          <p:cNvPr id="9" name="Shape 7"/>
-          <p:cNvSpPr/>
-          <p:nvPr/>
-        </p:nvSpPr>
-        <p:spPr>
-          <a:xfrm>
-            <a:off x="777240" y="3227832"/>
+          <p:cNvPr id="17" name="Shape 15"/>
+          <p:cNvSpPr/>
+          <p:nvPr/>
+        </p:nvSpPr>
+        <p:spPr>
+          <a:xfrm>
+            <a:off x="777240" y="4654296"/>
             <a:ext cx="502920" cy="502920"/>
           </a:xfrm>
           <a:prstGeom prst="ellipse">
@@ -4211,13 +4521,13 @@
       </p:sp>
       <p:sp>
         <p:nvSpPr>
-          <p:cNvPr id="10" name="Text 8"/>
-          <p:cNvSpPr/>
-          <p:nvPr/>
-        </p:nvSpPr>
-        <p:spPr>
-          <a:xfrm>
-            <a:off x="777240" y="3227832"/>
+          <p:cNvPr id="18" name="Text 16"/>
+          <p:cNvSpPr/>
+          <p:nvPr/>
+        </p:nvSpPr>
+        <p:spPr>
+          <a:xfrm>
+            <a:off x="777240" y="4654296"/>
             <a:ext cx="502920" cy="502920"/>
           </a:xfrm>
           <a:prstGeom prst="rect">
@@ -4242,7 +4552,7 @@
                 <a:ea typeface="Georgia" pitchFamily="34" charset="-122"/>
                 <a:cs typeface="Georgia" pitchFamily="34" charset="-120"/>
               </a:rPr>
-              <a:t>2</a:t>
+              <a:t>4</a:t>
             </a:r>
             <a:endParaRPr lang="en-US" sz="1800" dirty="0"/>
           </a:p>
@@ -4250,13 +4560,13 @@
       </p:sp>
       <p:sp>
         <p:nvSpPr>
-          <p:cNvPr id="11" name="Text 9"/>
-          <p:cNvSpPr/>
-          <p:nvPr/>
-        </p:nvSpPr>
-        <p:spPr>
-          <a:xfrm>
-            <a:off x="1508760" y="3182112"/>
+          <p:cNvPr id="19" name="Text 17"/>
+          <p:cNvSpPr/>
+          <p:nvPr/>
+        </p:nvSpPr>
+        <p:spPr>
+          <a:xfrm>
+            <a:off x="1417320" y="4709160"/>
             <a:ext cx="3657600" cy="365760"/>
           </a:xfrm>
           <a:prstGeom prst="rect">
@@ -4274,6 +4584,113 @@
             </a:pPr>
             <a:r>
               <a:rPr lang="en-US" sz="1600" b="1" dirty="0">
+                <a:solidFill>
+                  <a:srgbClr val="FFFFFF"/>
+                </a:solidFill>
+                <a:latin typeface="Comfortaa" pitchFamily="2" charset="0"/>
+                <a:ea typeface="Georgia" pitchFamily="34" charset="-122"/>
+                <a:cs typeface="Georgia" pitchFamily="34" charset="-120"/>
+              </a:rPr>
+              <a:t>Render to agent</a:t>
+            </a:r>
+            <a:endParaRPr lang="en-US" sz="1600" dirty="0">
+              <a:latin typeface="Comfortaa Medium" pitchFamily="2" charset="0"/>
+            </a:endParaRPr>
+          </a:p>
+        </p:txBody>
+      </p:sp>
+      <p:sp>
+        <p:nvSpPr>
+          <p:cNvPr id="20" name="Text 18"/>
+          <p:cNvSpPr/>
+          <p:nvPr/>
+        </p:nvSpPr>
+        <p:spPr>
+          <a:xfrm>
+            <a:off x="5212080" y="4654296"/>
+            <a:ext cx="6400800" cy="502920"/>
+          </a:xfrm>
+          <a:prstGeom prst="rect">
+            <a:avLst/>
+          </a:prstGeom>
+          <a:noFill/>
+          <a:ln/>
+        </p:spPr>
+        <p:txBody>
+          <a:bodyPr wrap="square" lIns="0" tIns="0" rIns="0" bIns="0" rtlCol="0" anchor="ctr"/>
+          <a:lstStyle/>
+          <a:p>
+            <a:pPr marL="0" indent="0">
+              <a:buNone/>
+            </a:pPr>
+            <a:r>
+              <a:rPr lang="en-US" sz="1200" dirty="0">
+                <a:solidFill>
+                  <a:srgbClr val="CFCFCF"/>
+                </a:solidFill>
+                <a:latin typeface="Calibri" pitchFamily="34" charset="0"/>
+                <a:ea typeface="Calibri" pitchFamily="34" charset="-122"/>
+                <a:cs typeface="Calibri" pitchFamily="34" charset="-120"/>
+              </a:rPr>
+              <a:t>Pipe the agent bundle as context for coding tasks on that feature.</a:t>
+            </a:r>
+            <a:endParaRPr lang="en-US" sz="1200" dirty="0"/>
+          </a:p>
+        </p:txBody>
+      </p:sp>
+      <p:sp>
+        <p:nvSpPr>
+          <p:cNvPr id="21" name="Shape 19"/>
+          <p:cNvSpPr/>
+          <p:nvPr/>
+        </p:nvSpPr>
+        <p:spPr>
+          <a:xfrm>
+            <a:off x="777240" y="5367528"/>
+            <a:ext cx="502920" cy="502920"/>
+          </a:xfrm>
+          <a:prstGeom prst="ellipse">
+            <a:avLst/>
+          </a:prstGeom>
+          <a:solidFill>
+            <a:srgbClr val="028090"/>
+          </a:solidFill>
+          <a:ln/>
+        </p:spPr>
+        <p:txBody>
+          <a:bodyPr/>
+          <a:lstStyle/>
+          <a:p>
+            <a:endParaRPr lang="en-US"/>
+          </a:p>
+        </p:txBody>
+      </p:sp>
+      <p:sp>
+        <p:nvSpPr>
+          <p:cNvPr id="22" name="Text 20"/>
+          <p:cNvSpPr/>
+          <p:nvPr/>
+        </p:nvSpPr>
+        <p:spPr>
+          <a:xfrm>
+            <a:off x="777240" y="5367528"/>
+            <a:ext cx="502920" cy="502920"/>
+          </a:xfrm>
+          <a:prstGeom prst="rect">
+            <a:avLst/>
+          </a:prstGeom>
+          <a:noFill/>
+          <a:ln/>
+        </p:spPr>
+        <p:txBody>
+          <a:bodyPr wrap="square" lIns="0" tIns="0" rIns="0" bIns="0" rtlCol="0" anchor="ctr"/>
+          <a:lstStyle/>
+          <a:p>
+            <a:pPr marL="0" indent="0" algn="ctr">
+              <a:buNone/>
+            </a:pPr>
+            <a:r>
+              <a:rPr lang="en-US" sz="1800" b="1" dirty="0">
                 <a:solidFill>
                   <a:srgbClr val="FFFFFF"/>
                 </a:solidFill>
@@ -4281,441 +4698,50 @@
                 <a:ea typeface="Georgia" pitchFamily="34" charset="-122"/>
                 <a:cs typeface="Georgia" pitchFamily="34" charset="-120"/>
               </a:rPr>
-              <a:t>Add the linter</a:t>
-            </a:r>
-            <a:endParaRPr lang="en-US" sz="1600" dirty="0"/>
-          </a:p>
-        </p:txBody>
-      </p:sp>
-      <p:sp>
-        <p:nvSpPr>
-          <p:cNvPr id="12" name="Text 10"/>
-          <p:cNvSpPr/>
-          <p:nvPr/>
-        </p:nvSpPr>
-        <p:spPr>
-          <a:xfrm>
-            <a:off x="5212080" y="3227832"/>
-            <a:ext cx="6400800" cy="502920"/>
-          </a:xfrm>
-          <a:prstGeom prst="rect">
-            <a:avLst/>
-          </a:prstGeom>
-          <a:noFill/>
-          <a:ln/>
-        </p:spPr>
-        <p:txBody>
-          <a:bodyPr wrap="square" lIns="0" tIns="0" rIns="0" bIns="0" rtlCol="0" anchor="ctr"/>
-          <a:lstStyle/>
-          <a:p>
-            <a:pPr marL="0" indent="0">
-              <a:buNone/>
-            </a:pPr>
-            <a:r>
-              <a:rPr lang="en-US" sz="1200" dirty="0">
-                <a:solidFill>
-                  <a:srgbClr val="CFCFCF"/>
-                </a:solidFill>
-                <a:latin typeface="Calibri" pitchFamily="34" charset="0"/>
-                <a:ea typeface="Calibri" pitchFamily="34" charset="-122"/>
-                <a:cs typeface="Calibri" pitchFamily="34" charset="-120"/>
-              </a:rPr>
-              <a:t>Wire `spec lint` into pre-commit. Errors stay manageable when the corpus is small.</a:t>
-            </a:r>
-            <a:endParaRPr lang="en-US" sz="1200" dirty="0"/>
-          </a:p>
-        </p:txBody>
-      </p:sp>
-      <p:sp>
-        <p:nvSpPr>
-          <p:cNvPr id="13" name="Shape 11"/>
-          <p:cNvSpPr/>
-          <p:nvPr/>
-        </p:nvSpPr>
-        <p:spPr>
-          <a:xfrm>
-            <a:off x="777240" y="3941064"/>
-            <a:ext cx="502920" cy="502920"/>
-          </a:xfrm>
-          <a:prstGeom prst="ellipse">
-            <a:avLst/>
-          </a:prstGeom>
-          <a:solidFill>
-            <a:srgbClr val="028090"/>
-          </a:solidFill>
-          <a:ln/>
-        </p:spPr>
-        <p:txBody>
-          <a:bodyPr/>
-          <a:lstStyle/>
-          <a:p>
-            <a:endParaRPr lang="en-US"/>
-          </a:p>
-        </p:txBody>
-      </p:sp>
-      <p:sp>
-        <p:nvSpPr>
-          <p:cNvPr id="14" name="Text 12"/>
-          <p:cNvSpPr/>
-          <p:nvPr/>
-        </p:nvSpPr>
-        <p:spPr>
-          <a:xfrm>
-            <a:off x="777240" y="3941064"/>
-            <a:ext cx="502920" cy="502920"/>
-          </a:xfrm>
-          <a:prstGeom prst="rect">
-            <a:avLst/>
-          </a:prstGeom>
-          <a:noFill/>
-          <a:ln/>
-        </p:spPr>
-        <p:txBody>
-          <a:bodyPr wrap="square" lIns="0" tIns="0" rIns="0" bIns="0" rtlCol="0" anchor="ctr"/>
-          <a:lstStyle/>
-          <a:p>
-            <a:pPr marL="0" indent="0" algn="ctr">
-              <a:buNone/>
-            </a:pPr>
-            <a:r>
-              <a:rPr lang="en-US" sz="1800" b="1" dirty="0">
+              <a:t>5</a:t>
+            </a:r>
+            <a:endParaRPr lang="en-US" sz="1800" dirty="0"/>
+          </a:p>
+        </p:txBody>
+      </p:sp>
+      <p:sp>
+        <p:nvSpPr>
+          <p:cNvPr id="23" name="Text 21"/>
+          <p:cNvSpPr/>
+          <p:nvPr/>
+        </p:nvSpPr>
+        <p:spPr>
+          <a:xfrm>
+            <a:off x="1417320" y="5422392"/>
+            <a:ext cx="3657600" cy="365760"/>
+          </a:xfrm>
+          <a:prstGeom prst="rect">
+            <a:avLst/>
+          </a:prstGeom>
+          <a:noFill/>
+          <a:ln/>
+        </p:spPr>
+        <p:txBody>
+          <a:bodyPr wrap="square" lIns="0" tIns="0" rIns="0" bIns="0" rtlCol="0" anchor="ctr"/>
+          <a:lstStyle/>
+          <a:p>
+            <a:pPr marL="0" indent="0">
+              <a:buNone/>
+            </a:pPr>
+            <a:r>
+              <a:rPr lang="en-US" sz="1600" b="1" dirty="0">
                 <a:solidFill>
                   <a:srgbClr val="FFFFFF"/>
                 </a:solidFill>
-                <a:latin typeface="Georgia" pitchFamily="34" charset="0"/>
+                <a:latin typeface="Comfortaa" pitchFamily="2" charset="0"/>
                 <a:ea typeface="Georgia" pitchFamily="34" charset="-122"/>
                 <a:cs typeface="Georgia" pitchFamily="34" charset="-120"/>
               </a:rPr>
-              <a:t>3</a:t>
-            </a:r>
-            <a:endParaRPr lang="en-US" sz="1800" dirty="0"/>
-          </a:p>
-        </p:txBody>
-      </p:sp>
-      <p:sp>
-        <p:nvSpPr>
-          <p:cNvPr id="15" name="Text 13"/>
-          <p:cNvSpPr/>
-          <p:nvPr/>
-        </p:nvSpPr>
-        <p:spPr>
-          <a:xfrm>
-            <a:off x="1508760" y="3895344"/>
-            <a:ext cx="3657600" cy="365760"/>
-          </a:xfrm>
-          <a:prstGeom prst="rect">
-            <a:avLst/>
-          </a:prstGeom>
-          <a:noFill/>
-          <a:ln/>
-        </p:spPr>
-        <p:txBody>
-          <a:bodyPr wrap="square" lIns="0" tIns="0" rIns="0" bIns="0" rtlCol="0" anchor="ctr"/>
-          <a:lstStyle/>
-          <a:p>
-            <a:pPr marL="0" indent="0">
-              <a:buNone/>
-            </a:pPr>
-            <a:r>
-              <a:rPr lang="en-US" sz="1600" b="1" dirty="0">
-                <a:solidFill>
-                  <a:srgbClr val="FFFFFF"/>
-                </a:solidFill>
-                <a:latin typeface="Georgia" pitchFamily="34" charset="0"/>
-                <a:ea typeface="Georgia" pitchFamily="34" charset="-122"/>
-                <a:cs typeface="Georgia" pitchFamily="34" charset="-120"/>
-              </a:rPr>
-              <a:t>Trailer commits</a:t>
-            </a:r>
-            <a:endParaRPr lang="en-US" sz="1600" dirty="0"/>
-          </a:p>
-        </p:txBody>
-      </p:sp>
-      <p:sp>
-        <p:nvSpPr>
-          <p:cNvPr id="16" name="Text 14"/>
-          <p:cNvSpPr/>
-          <p:nvPr/>
-        </p:nvSpPr>
-        <p:spPr>
-          <a:xfrm>
-            <a:off x="5212080" y="3941064"/>
-            <a:ext cx="6400800" cy="502920"/>
-          </a:xfrm>
-          <a:prstGeom prst="rect">
-            <a:avLst/>
-          </a:prstGeom>
-          <a:noFill/>
-          <a:ln/>
-        </p:spPr>
-        <p:txBody>
-          <a:bodyPr wrap="square" lIns="0" tIns="0" rIns="0" bIns="0" rtlCol="0" anchor="ctr"/>
-          <a:lstStyle/>
-          <a:p>
-            <a:pPr marL="0" indent="0">
-              <a:buNone/>
-            </a:pPr>
-            <a:r>
-              <a:rPr lang="en-US" sz="1200" dirty="0">
-                <a:solidFill>
-                  <a:srgbClr val="CFCFCF"/>
-                </a:solidFill>
-                <a:latin typeface="Calibri" pitchFamily="34" charset="0"/>
-                <a:ea typeface="Calibri" pitchFamily="34" charset="-122"/>
-                <a:cs typeface="Calibri" pitchFamily="34" charset="-120"/>
-              </a:rPr>
-              <a:t>Start adding Spec-Ref to commit messages. History fills in over time.</a:t>
-            </a:r>
-            <a:endParaRPr lang="en-US" sz="1200" dirty="0"/>
-          </a:p>
-        </p:txBody>
-      </p:sp>
-      <p:sp>
-        <p:nvSpPr>
-          <p:cNvPr id="17" name="Shape 15"/>
-          <p:cNvSpPr/>
-          <p:nvPr/>
-        </p:nvSpPr>
-        <p:spPr>
-          <a:xfrm>
-            <a:off x="777240" y="4654296"/>
-            <a:ext cx="502920" cy="502920"/>
-          </a:xfrm>
-          <a:prstGeom prst="ellipse">
-            <a:avLst/>
-          </a:prstGeom>
-          <a:solidFill>
-            <a:srgbClr val="028090"/>
-          </a:solidFill>
-          <a:ln/>
-        </p:spPr>
-        <p:txBody>
-          <a:bodyPr/>
-          <a:lstStyle/>
-          <a:p>
-            <a:endParaRPr lang="en-US"/>
-          </a:p>
-        </p:txBody>
-      </p:sp>
-      <p:sp>
-        <p:nvSpPr>
-          <p:cNvPr id="18" name="Text 16"/>
-          <p:cNvSpPr/>
-          <p:nvPr/>
-        </p:nvSpPr>
-        <p:spPr>
-          <a:xfrm>
-            <a:off x="777240" y="4654296"/>
-            <a:ext cx="502920" cy="502920"/>
-          </a:xfrm>
-          <a:prstGeom prst="rect">
-            <a:avLst/>
-          </a:prstGeom>
-          <a:noFill/>
-          <a:ln/>
-        </p:spPr>
-        <p:txBody>
-          <a:bodyPr wrap="square" lIns="0" tIns="0" rIns="0" bIns="0" rtlCol="0" anchor="ctr"/>
-          <a:lstStyle/>
-          <a:p>
-            <a:pPr marL="0" indent="0" algn="ctr">
-              <a:buNone/>
-            </a:pPr>
-            <a:r>
-              <a:rPr lang="en-US" sz="1800" b="1" dirty="0">
-                <a:solidFill>
-                  <a:srgbClr val="FFFFFF"/>
-                </a:solidFill>
-                <a:latin typeface="Georgia" pitchFamily="34" charset="0"/>
-                <a:ea typeface="Georgia" pitchFamily="34" charset="-122"/>
-                <a:cs typeface="Georgia" pitchFamily="34" charset="-120"/>
-              </a:rPr>
-              <a:t>4</a:t>
-            </a:r>
-            <a:endParaRPr lang="en-US" sz="1800" dirty="0"/>
-          </a:p>
-        </p:txBody>
-      </p:sp>
-      <p:sp>
-        <p:nvSpPr>
-          <p:cNvPr id="19" name="Text 17"/>
-          <p:cNvSpPr/>
-          <p:nvPr/>
-        </p:nvSpPr>
-        <p:spPr>
-          <a:xfrm>
-            <a:off x="1508760" y="4608576"/>
-            <a:ext cx="3657600" cy="365760"/>
-          </a:xfrm>
-          <a:prstGeom prst="rect">
-            <a:avLst/>
-          </a:prstGeom>
-          <a:noFill/>
-          <a:ln/>
-        </p:spPr>
-        <p:txBody>
-          <a:bodyPr wrap="square" lIns="0" tIns="0" rIns="0" bIns="0" rtlCol="0" anchor="ctr"/>
-          <a:lstStyle/>
-          <a:p>
-            <a:pPr marL="0" indent="0">
-              <a:buNone/>
-            </a:pPr>
-            <a:r>
-              <a:rPr lang="en-US" sz="1600" b="1" dirty="0">
-                <a:solidFill>
-                  <a:srgbClr val="FFFFFF"/>
-                </a:solidFill>
-                <a:latin typeface="Georgia" pitchFamily="34" charset="0"/>
-                <a:ea typeface="Georgia" pitchFamily="34" charset="-122"/>
-                <a:cs typeface="Georgia" pitchFamily="34" charset="-120"/>
-              </a:rPr>
-              <a:t>Render to agent</a:t>
-            </a:r>
-            <a:endParaRPr lang="en-US" sz="1600" dirty="0"/>
-          </a:p>
-        </p:txBody>
-      </p:sp>
-      <p:sp>
-        <p:nvSpPr>
-          <p:cNvPr id="20" name="Text 18"/>
-          <p:cNvSpPr/>
-          <p:nvPr/>
-        </p:nvSpPr>
-        <p:spPr>
-          <a:xfrm>
-            <a:off x="5212080" y="4654296"/>
-            <a:ext cx="6400800" cy="502920"/>
-          </a:xfrm>
-          <a:prstGeom prst="rect">
-            <a:avLst/>
-          </a:prstGeom>
-          <a:noFill/>
-          <a:ln/>
-        </p:spPr>
-        <p:txBody>
-          <a:bodyPr wrap="square" lIns="0" tIns="0" rIns="0" bIns="0" rtlCol="0" anchor="ctr"/>
-          <a:lstStyle/>
-          <a:p>
-            <a:pPr marL="0" indent="0">
-              <a:buNone/>
-            </a:pPr>
-            <a:r>
-              <a:rPr lang="en-US" sz="1200" dirty="0">
-                <a:solidFill>
-                  <a:srgbClr val="CFCFCF"/>
-                </a:solidFill>
-                <a:latin typeface="Calibri" pitchFamily="34" charset="0"/>
-                <a:ea typeface="Calibri" pitchFamily="34" charset="-122"/>
-                <a:cs typeface="Calibri" pitchFamily="34" charset="-120"/>
-              </a:rPr>
-              <a:t>Pipe the agent bundle as context for coding tasks on that feature.</a:t>
-            </a:r>
-            <a:endParaRPr lang="en-US" sz="1200" dirty="0"/>
-          </a:p>
-        </p:txBody>
-      </p:sp>
-      <p:sp>
-        <p:nvSpPr>
-          <p:cNvPr id="21" name="Shape 19"/>
-          <p:cNvSpPr/>
-          <p:nvPr/>
-        </p:nvSpPr>
-        <p:spPr>
-          <a:xfrm>
-            <a:off x="777240" y="5367528"/>
-            <a:ext cx="502920" cy="502920"/>
-          </a:xfrm>
-          <a:prstGeom prst="ellipse">
-            <a:avLst/>
-          </a:prstGeom>
-          <a:solidFill>
-            <a:srgbClr val="028090"/>
-          </a:solidFill>
-          <a:ln/>
-        </p:spPr>
-        <p:txBody>
-          <a:bodyPr/>
-          <a:lstStyle/>
-          <a:p>
-            <a:endParaRPr lang="en-US"/>
-          </a:p>
-        </p:txBody>
-      </p:sp>
-      <p:sp>
-        <p:nvSpPr>
-          <p:cNvPr id="22" name="Text 20"/>
-          <p:cNvSpPr/>
-          <p:nvPr/>
-        </p:nvSpPr>
-        <p:spPr>
-          <a:xfrm>
-            <a:off x="777240" y="5367528"/>
-            <a:ext cx="502920" cy="502920"/>
-          </a:xfrm>
-          <a:prstGeom prst="rect">
-            <a:avLst/>
-          </a:prstGeom>
-          <a:noFill/>
-          <a:ln/>
-        </p:spPr>
-        <p:txBody>
-          <a:bodyPr wrap="square" lIns="0" tIns="0" rIns="0" bIns="0" rtlCol="0" anchor="ctr"/>
-          <a:lstStyle/>
-          <a:p>
-            <a:pPr marL="0" indent="0" algn="ctr">
-              <a:buNone/>
-            </a:pPr>
-            <a:r>
-              <a:rPr lang="en-US" sz="1800" b="1" dirty="0">
-                <a:solidFill>
-                  <a:srgbClr val="FFFFFF"/>
-                </a:solidFill>
-                <a:latin typeface="Georgia" pitchFamily="34" charset="0"/>
-                <a:ea typeface="Georgia" pitchFamily="34" charset="-122"/>
-                <a:cs typeface="Georgia" pitchFamily="34" charset="-120"/>
-              </a:rPr>
-              <a:t>5</a:t>
-            </a:r>
-            <a:endParaRPr lang="en-US" sz="1800" dirty="0"/>
-          </a:p>
-        </p:txBody>
-      </p:sp>
-      <p:sp>
-        <p:nvSpPr>
-          <p:cNvPr id="23" name="Text 21"/>
-          <p:cNvSpPr/>
-          <p:nvPr/>
-        </p:nvSpPr>
-        <p:spPr>
-          <a:xfrm>
-            <a:off x="1508760" y="5321808"/>
-            <a:ext cx="3657600" cy="365760"/>
-          </a:xfrm>
-          <a:prstGeom prst="rect">
-            <a:avLst/>
-          </a:prstGeom>
-          <a:noFill/>
-          <a:ln/>
-        </p:spPr>
-        <p:txBody>
-          <a:bodyPr wrap="square" lIns="0" tIns="0" rIns="0" bIns="0" rtlCol="0" anchor="ctr"/>
-          <a:lstStyle/>
-          <a:p>
-            <a:pPr marL="0" indent="0">
-              <a:buNone/>
-            </a:pPr>
-            <a:r>
-              <a:rPr lang="en-US" sz="1600" b="1" dirty="0">
-                <a:solidFill>
-                  <a:srgbClr val="FFFFFF"/>
-                </a:solidFill>
-                <a:latin typeface="Georgia" pitchFamily="34" charset="0"/>
-                <a:ea typeface="Georgia" pitchFamily="34" charset="-122"/>
-                <a:cs typeface="Georgia" pitchFamily="34" charset="-120"/>
-              </a:rPr>
               <a:t>Expand by demand</a:t>
             </a:r>
-            <a:endParaRPr lang="en-US" sz="1600" dirty="0"/>
+            <a:endParaRPr lang="en-US" sz="1600" dirty="0">
+              <a:latin typeface="Comfortaa Medium" pitchFamily="2" charset="0"/>
+            </a:endParaRPr>
           </a:p>
         </p:txBody>
       </p:sp>
@@ -4859,13 +4885,15 @@
                 <a:solidFill>
                   <a:srgbClr val="1A1A1A"/>
                 </a:solidFill>
-                <a:latin typeface="Georgia" pitchFamily="34" charset="0"/>
+                <a:latin typeface="Comfortaa" pitchFamily="2" charset="0"/>
                 <a:ea typeface="Georgia" pitchFamily="34" charset="-122"/>
                 <a:cs typeface="Georgia" pitchFamily="34" charset="-120"/>
               </a:rPr>
               <a:t>The problem</a:t>
             </a:r>
-            <a:endParaRPr lang="en-US" sz="3000" dirty="0"/>
+            <a:endParaRPr lang="en-US" sz="3000" dirty="0">
+              <a:latin typeface="Comfortaa Medium" pitchFamily="2" charset="0"/>
+            </a:endParaRPr>
           </a:p>
         </p:txBody>
       </p:sp>
@@ -4996,13 +5024,15 @@
                 <a:solidFill>
                   <a:srgbClr val="1A1A1A"/>
                 </a:solidFill>
-                <a:latin typeface="Georgia" pitchFamily="34" charset="0"/>
+                <a:latin typeface="Comfortaa" pitchFamily="2" charset="0"/>
                 <a:ea typeface="Georgia" pitchFamily="34" charset="-122"/>
                 <a:cs typeface="Georgia" pitchFamily="34" charset="-120"/>
               </a:rPr>
               <a:t>Plain Markdown</a:t>
             </a:r>
-            <a:endParaRPr lang="en-US" sz="1800" dirty="0"/>
+            <a:endParaRPr lang="en-US" sz="1800" dirty="0">
+              <a:latin typeface="Comfortaa Medium" pitchFamily="2" charset="0"/>
+            </a:endParaRPr>
           </a:p>
         </p:txBody>
       </p:sp>
@@ -5261,13 +5291,15 @@
                 <a:solidFill>
                   <a:srgbClr val="1A1A1A"/>
                 </a:solidFill>
-                <a:latin typeface="Georgia" pitchFamily="34" charset="0"/>
+                <a:latin typeface="Comfortaa" pitchFamily="2" charset="0"/>
                 <a:ea typeface="Georgia" pitchFamily="34" charset="-122"/>
                 <a:cs typeface="Georgia" pitchFamily="34" charset="-120"/>
               </a:rPr>
               <a:t>Pure structured (DOORS / ReqIF / YAML-only)</a:t>
             </a:r>
-            <a:endParaRPr lang="en-US" sz="1800" dirty="0"/>
+            <a:endParaRPr lang="en-US" sz="1800" dirty="0">
+              <a:latin typeface="Comfortaa Medium" pitchFamily="2" charset="0"/>
+            </a:endParaRPr>
           </a:p>
         </p:txBody>
       </p:sp>
@@ -5617,42 +5649,190 @@
                 <a:solidFill>
                   <a:srgbClr val="1A1A1A"/>
                 </a:solidFill>
+                <a:latin typeface="Comfortaa" pitchFamily="2" charset="0"/>
+                <a:ea typeface="Georgia" pitchFamily="34" charset="-122"/>
+                <a:cs typeface="Georgia" pitchFamily="34" charset="-120"/>
+              </a:rPr>
+              <a:t>What we want from the format</a:t>
+            </a:r>
+            <a:endParaRPr lang="en-US" sz="3000" dirty="0">
+              <a:latin typeface="Comfortaa Medium" pitchFamily="2" charset="0"/>
+            </a:endParaRPr>
+          </a:p>
+        </p:txBody>
+      </p:sp>
+      <p:sp>
+        <p:nvSpPr>
+          <p:cNvPr id="3" name="Text 1"/>
+          <p:cNvSpPr/>
+          <p:nvPr/>
+        </p:nvSpPr>
+        <p:spPr>
+          <a:xfrm>
+            <a:off x="548640" y="1005840"/>
+            <a:ext cx="11064240" cy="365760"/>
+          </a:xfrm>
+          <a:prstGeom prst="rect">
+            <a:avLst/>
+          </a:prstGeom>
+          <a:noFill/>
+          <a:ln/>
+        </p:spPr>
+        <p:txBody>
+          <a:bodyPr wrap="square" lIns="0" tIns="0" rIns="0" bIns="0" rtlCol="0" anchor="ctr"/>
+          <a:lstStyle/>
+          <a:p>
+            <a:pPr marL="0" indent="0">
+              <a:buNone/>
+            </a:pPr>
+            <a:r>
+              <a:rPr lang="en-US" sz="1400" i="1" dirty="0">
+                <a:solidFill>
+                  <a:srgbClr val="6B6B6B"/>
+                </a:solidFill>
+                <a:latin typeface="Calibri" pitchFamily="34" charset="0"/>
+                <a:ea typeface="Calibri" pitchFamily="34" charset="-122"/>
+                <a:cs typeface="Calibri" pitchFamily="34" charset="-120"/>
+              </a:rPr>
+              <a:t>Five properties, all required</a:t>
+            </a:r>
+            <a:endParaRPr lang="en-US" sz="1400" dirty="0"/>
+          </a:p>
+        </p:txBody>
+      </p:sp>
+      <p:sp>
+        <p:nvSpPr>
+          <p:cNvPr id="4" name="Shape 2"/>
+          <p:cNvSpPr/>
+          <p:nvPr/>
+        </p:nvSpPr>
+        <p:spPr>
+          <a:xfrm>
+            <a:off x="640080" y="1737360"/>
+            <a:ext cx="640080" cy="640080"/>
+          </a:xfrm>
+          <a:prstGeom prst="ellipse">
+            <a:avLst/>
+          </a:prstGeom>
+          <a:solidFill>
+            <a:srgbClr val="028090"/>
+          </a:solidFill>
+          <a:ln/>
+        </p:spPr>
+        <p:txBody>
+          <a:bodyPr/>
+          <a:lstStyle/>
+          <a:p>
+            <a:endParaRPr lang="en-US"/>
+          </a:p>
+        </p:txBody>
+      </p:sp>
+      <p:sp>
+        <p:nvSpPr>
+          <p:cNvPr id="5" name="Text 3"/>
+          <p:cNvSpPr/>
+          <p:nvPr/>
+        </p:nvSpPr>
+        <p:spPr>
+          <a:xfrm>
+            <a:off x="640080" y="1737360"/>
+            <a:ext cx="640080" cy="640080"/>
+          </a:xfrm>
+          <a:prstGeom prst="rect">
+            <a:avLst/>
+          </a:prstGeom>
+          <a:noFill/>
+          <a:ln/>
+        </p:spPr>
+        <p:txBody>
+          <a:bodyPr wrap="square" lIns="0" tIns="0" rIns="0" bIns="0" rtlCol="0" anchor="ctr"/>
+          <a:lstStyle/>
+          <a:p>
+            <a:pPr marL="0" indent="0" algn="ctr">
+              <a:buNone/>
+            </a:pPr>
+            <a:r>
+              <a:rPr lang="en-US" sz="2400" b="1" dirty="0">
+                <a:solidFill>
+                  <a:srgbClr val="FFFFFF"/>
+                </a:solidFill>
                 <a:latin typeface="Georgia" pitchFamily="34" charset="0"/>
                 <a:ea typeface="Georgia" pitchFamily="34" charset="-122"/>
                 <a:cs typeface="Georgia" pitchFamily="34" charset="-120"/>
               </a:rPr>
-              <a:t>What we want from the format</a:t>
-            </a:r>
-            <a:endParaRPr lang="en-US" sz="3000" dirty="0"/>
-          </a:p>
-        </p:txBody>
-      </p:sp>
-      <p:sp>
-        <p:nvSpPr>
-          <p:cNvPr id="3" name="Text 1"/>
-          <p:cNvSpPr/>
-          <p:nvPr/>
-        </p:nvSpPr>
-        <p:spPr>
-          <a:xfrm>
-            <a:off x="548640" y="1005840"/>
-            <a:ext cx="11064240" cy="365760"/>
-          </a:xfrm>
-          <a:prstGeom prst="rect">
-            <a:avLst/>
-          </a:prstGeom>
-          <a:noFill/>
-          <a:ln/>
-        </p:spPr>
-        <p:txBody>
-          <a:bodyPr wrap="square" lIns="0" tIns="0" rIns="0" bIns="0" rtlCol="0" anchor="ctr"/>
-          <a:lstStyle/>
-          <a:p>
-            <a:pPr marL="0" indent="0">
-              <a:buNone/>
-            </a:pPr>
-            <a:r>
-              <a:rPr lang="en-US" sz="1400" i="1" dirty="0">
+              <a:t>1</a:t>
+            </a:r>
+            <a:endParaRPr lang="en-US" sz="2400" dirty="0"/>
+          </a:p>
+        </p:txBody>
+      </p:sp>
+      <p:sp>
+        <p:nvSpPr>
+          <p:cNvPr id="6" name="Text 4"/>
+          <p:cNvSpPr/>
+          <p:nvPr/>
+        </p:nvSpPr>
+        <p:spPr>
+          <a:xfrm>
+            <a:off x="1554480" y="1737360"/>
+            <a:ext cx="2743200" cy="365760"/>
+          </a:xfrm>
+          <a:prstGeom prst="rect">
+            <a:avLst/>
+          </a:prstGeom>
+          <a:noFill/>
+          <a:ln/>
+        </p:spPr>
+        <p:txBody>
+          <a:bodyPr wrap="square" lIns="0" tIns="0" rIns="0" bIns="0" rtlCol="0" anchor="ctr"/>
+          <a:lstStyle/>
+          <a:p>
+            <a:pPr marL="0" indent="0">
+              <a:buNone/>
+            </a:pPr>
+            <a:r>
+              <a:rPr lang="en-US" sz="1800" b="1" dirty="0">
+                <a:solidFill>
+                  <a:srgbClr val="1A1A1A"/>
+                </a:solidFill>
+                <a:latin typeface="Comfortaa" pitchFamily="2" charset="0"/>
+                <a:ea typeface="Georgia" pitchFamily="34" charset="-122"/>
+                <a:cs typeface="Georgia" pitchFamily="34" charset="-120"/>
+              </a:rPr>
+              <a:t>Precise</a:t>
+            </a:r>
+            <a:endParaRPr lang="en-US" sz="1800" dirty="0">
+              <a:latin typeface="Comfortaa Medium" pitchFamily="2" charset="0"/>
+            </a:endParaRPr>
+          </a:p>
+        </p:txBody>
+      </p:sp>
+      <p:sp>
+        <p:nvSpPr>
+          <p:cNvPr id="7" name="Text 5"/>
+          <p:cNvSpPr/>
+          <p:nvPr/>
+        </p:nvSpPr>
+        <p:spPr>
+          <a:xfrm>
+            <a:off x="1554480" y="1965960"/>
+            <a:ext cx="10058400" cy="365760"/>
+          </a:xfrm>
+          <a:prstGeom prst="rect">
+            <a:avLst/>
+          </a:prstGeom>
+          <a:noFill/>
+          <a:ln/>
+        </p:spPr>
+        <p:txBody>
+          <a:bodyPr wrap="square" lIns="0" tIns="0" rIns="0" bIns="0" rtlCol="0" anchor="ctr"/>
+          <a:lstStyle/>
+          <a:p>
+            <a:pPr marL="0" indent="0">
+              <a:buNone/>
+            </a:pPr>
+            <a:r>
+              <a:rPr lang="en-US" sz="1300" dirty="0">
                 <a:solidFill>
                   <a:srgbClr val="6B6B6B"/>
                 </a:solidFill>
@@ -5660,21 +5840,21 @@
                 <a:ea typeface="Calibri" pitchFamily="34" charset="-122"/>
                 <a:cs typeface="Calibri" pitchFamily="34" charset="-120"/>
               </a:rPr>
-              <a:t>Five properties, all required</a:t>
-            </a:r>
-            <a:endParaRPr lang="en-US" sz="1400" dirty="0"/>
-          </a:p>
-        </p:txBody>
-      </p:sp>
-      <p:sp>
-        <p:nvSpPr>
-          <p:cNvPr id="4" name="Shape 2"/>
-          <p:cNvSpPr/>
-          <p:nvPr/>
-        </p:nvSpPr>
-        <p:spPr>
-          <a:xfrm>
-            <a:off x="640080" y="1737360"/>
+              <a:t>Schema-validated; agents can rely on shape, not vibes.</a:t>
+            </a:r>
+            <a:endParaRPr lang="en-US" sz="1300" dirty="0"/>
+          </a:p>
+        </p:txBody>
+      </p:sp>
+      <p:sp>
+        <p:nvSpPr>
+          <p:cNvPr id="8" name="Shape 6"/>
+          <p:cNvSpPr/>
+          <p:nvPr/>
+        </p:nvSpPr>
+        <p:spPr>
+          <a:xfrm>
+            <a:off x="640080" y="2606040"/>
             <a:ext cx="640080" cy="640080"/>
           </a:xfrm>
           <a:prstGeom prst="ellipse">
@@ -5695,13 +5875,13 @@
       </p:sp>
       <p:sp>
         <p:nvSpPr>
-          <p:cNvPr id="5" name="Text 3"/>
-          <p:cNvSpPr/>
-          <p:nvPr/>
-        </p:nvSpPr>
-        <p:spPr>
-          <a:xfrm>
-            <a:off x="640080" y="1737360"/>
+          <p:cNvPr id="9" name="Text 7"/>
+          <p:cNvSpPr/>
+          <p:nvPr/>
+        </p:nvSpPr>
+        <p:spPr>
+          <a:xfrm>
+            <a:off x="640080" y="2606040"/>
             <a:ext cx="640080" cy="640080"/>
           </a:xfrm>
           <a:prstGeom prst="rect">
@@ -5726,7 +5906,7 @@
                 <a:ea typeface="Georgia" pitchFamily="34" charset="-122"/>
                 <a:cs typeface="Georgia" pitchFamily="34" charset="-120"/>
               </a:rPr>
-              <a:t>1</a:t>
+              <a:t>2</a:t>
             </a:r>
             <a:endParaRPr lang="en-US" sz="2400" dirty="0"/>
           </a:p>
@@ -5734,13 +5914,13 @@
       </p:sp>
       <p:sp>
         <p:nvSpPr>
-          <p:cNvPr id="6" name="Text 4"/>
-          <p:cNvSpPr/>
-          <p:nvPr/>
-        </p:nvSpPr>
-        <p:spPr>
-          <a:xfrm>
-            <a:off x="1554480" y="1737360"/>
+          <p:cNvPr id="10" name="Text 8"/>
+          <p:cNvSpPr/>
+          <p:nvPr/>
+        </p:nvSpPr>
+        <p:spPr>
+          <a:xfrm>
+            <a:off x="1554480" y="2606040"/>
             <a:ext cx="2743200" cy="365760"/>
           </a:xfrm>
           <a:prstGeom prst="rect">
@@ -5760,26 +5940,174 @@
               <a:rPr lang="en-US" sz="1800" b="1" dirty="0">
                 <a:solidFill>
                   <a:srgbClr val="1A1A1A"/>
+                </a:solidFill>
+                <a:latin typeface="Comfortaa" pitchFamily="2" charset="0"/>
+                <a:ea typeface="Georgia" pitchFamily="34" charset="-122"/>
+                <a:cs typeface="Georgia" pitchFamily="34" charset="-120"/>
+              </a:rPr>
+              <a:t>Readable</a:t>
+            </a:r>
+            <a:endParaRPr lang="en-US" sz="1800" dirty="0">
+              <a:latin typeface="Comfortaa Medium" pitchFamily="2" charset="0"/>
+            </a:endParaRPr>
+          </a:p>
+        </p:txBody>
+      </p:sp>
+      <p:sp>
+        <p:nvSpPr>
+          <p:cNvPr id="11" name="Text 9"/>
+          <p:cNvSpPr/>
+          <p:nvPr/>
+        </p:nvSpPr>
+        <p:spPr>
+          <a:xfrm>
+            <a:off x="1554480" y="2834640"/>
+            <a:ext cx="10058400" cy="365760"/>
+          </a:xfrm>
+          <a:prstGeom prst="rect">
+            <a:avLst/>
+          </a:prstGeom>
+          <a:noFill/>
+          <a:ln/>
+        </p:spPr>
+        <p:txBody>
+          <a:bodyPr wrap="square" lIns="0" tIns="0" rIns="0" bIns="0" rtlCol="0" anchor="ctr"/>
+          <a:lstStyle/>
+          <a:p>
+            <a:pPr marL="0" indent="0">
+              <a:buNone/>
+            </a:pPr>
+            <a:r>
+              <a:rPr lang="en-US" sz="1300" dirty="0">
+                <a:solidFill>
+                  <a:srgbClr val="6B6B6B"/>
+                </a:solidFill>
+                <a:latin typeface="Calibri" pitchFamily="34" charset="0"/>
+                <a:ea typeface="Calibri" pitchFamily="34" charset="-122"/>
+                <a:cs typeface="Calibri" pitchFamily="34" charset="-120"/>
+              </a:rPr>
+              <a:t>Canonical form is Markdown. Reviewable in a PR like any other text.</a:t>
+            </a:r>
+            <a:endParaRPr lang="en-US" sz="1300" dirty="0"/>
+          </a:p>
+        </p:txBody>
+      </p:sp>
+      <p:sp>
+        <p:nvSpPr>
+          <p:cNvPr id="12" name="Shape 10"/>
+          <p:cNvSpPr/>
+          <p:nvPr/>
+        </p:nvSpPr>
+        <p:spPr>
+          <a:xfrm>
+            <a:off x="640080" y="3474720"/>
+            <a:ext cx="640080" cy="640080"/>
+          </a:xfrm>
+          <a:prstGeom prst="ellipse">
+            <a:avLst/>
+          </a:prstGeom>
+          <a:solidFill>
+            <a:srgbClr val="028090"/>
+          </a:solidFill>
+          <a:ln/>
+        </p:spPr>
+        <p:txBody>
+          <a:bodyPr/>
+          <a:lstStyle/>
+          <a:p>
+            <a:endParaRPr lang="en-US"/>
+          </a:p>
+        </p:txBody>
+      </p:sp>
+      <p:sp>
+        <p:nvSpPr>
+          <p:cNvPr id="13" name="Text 11"/>
+          <p:cNvSpPr/>
+          <p:nvPr/>
+        </p:nvSpPr>
+        <p:spPr>
+          <a:xfrm>
+            <a:off x="640080" y="3474720"/>
+            <a:ext cx="640080" cy="640080"/>
+          </a:xfrm>
+          <a:prstGeom prst="rect">
+            <a:avLst/>
+          </a:prstGeom>
+          <a:noFill/>
+          <a:ln/>
+        </p:spPr>
+        <p:txBody>
+          <a:bodyPr wrap="square" lIns="0" tIns="0" rIns="0" bIns="0" rtlCol="0" anchor="ctr"/>
+          <a:lstStyle/>
+          <a:p>
+            <a:pPr marL="0" indent="0" algn="ctr">
+              <a:buNone/>
+            </a:pPr>
+            <a:r>
+              <a:rPr lang="en-US" sz="2400" b="1" dirty="0">
+                <a:solidFill>
+                  <a:srgbClr val="FFFFFF"/>
                 </a:solidFill>
                 <a:latin typeface="Georgia" pitchFamily="34" charset="0"/>
                 <a:ea typeface="Georgia" pitchFamily="34" charset="-122"/>
                 <a:cs typeface="Georgia" pitchFamily="34" charset="-120"/>
               </a:rPr>
-              <a:t>Precise</a:t>
-            </a:r>
-            <a:endParaRPr lang="en-US" sz="1800" dirty="0"/>
-          </a:p>
-        </p:txBody>
-      </p:sp>
-      <p:sp>
-        <p:nvSpPr>
-          <p:cNvPr id="7" name="Text 5"/>
-          <p:cNvSpPr/>
-          <p:nvPr/>
-        </p:nvSpPr>
-        <p:spPr>
-          <a:xfrm>
-            <a:off x="1554480" y="2103120"/>
+              <a:t>3</a:t>
+            </a:r>
+            <a:endParaRPr lang="en-US" sz="2400" dirty="0"/>
+          </a:p>
+        </p:txBody>
+      </p:sp>
+      <p:sp>
+        <p:nvSpPr>
+          <p:cNvPr id="14" name="Text 12"/>
+          <p:cNvSpPr/>
+          <p:nvPr/>
+        </p:nvSpPr>
+        <p:spPr>
+          <a:xfrm>
+            <a:off x="1554480" y="3474720"/>
+            <a:ext cx="2743200" cy="365760"/>
+          </a:xfrm>
+          <a:prstGeom prst="rect">
+            <a:avLst/>
+          </a:prstGeom>
+          <a:noFill/>
+          <a:ln/>
+        </p:spPr>
+        <p:txBody>
+          <a:bodyPr wrap="square" lIns="0" tIns="0" rIns="0" bIns="0" rtlCol="0" anchor="ctr"/>
+          <a:lstStyle/>
+          <a:p>
+            <a:pPr marL="0" indent="0">
+              <a:buNone/>
+            </a:pPr>
+            <a:r>
+              <a:rPr lang="en-US" sz="1800" b="1" dirty="0">
+                <a:solidFill>
+                  <a:srgbClr val="1A1A1A"/>
+                </a:solidFill>
+                <a:latin typeface="Comfortaa" pitchFamily="2" charset="0"/>
+                <a:ea typeface="Georgia" pitchFamily="34" charset="-122"/>
+                <a:cs typeface="Georgia" pitchFamily="34" charset="-120"/>
+              </a:rPr>
+              <a:t>Linked</a:t>
+            </a:r>
+            <a:endParaRPr lang="en-US" sz="1800" dirty="0">
+              <a:latin typeface="Comfortaa Medium" pitchFamily="2" charset="0"/>
+            </a:endParaRPr>
+          </a:p>
+        </p:txBody>
+      </p:sp>
+      <p:sp>
+        <p:nvSpPr>
+          <p:cNvPr id="15" name="Text 13"/>
+          <p:cNvSpPr/>
+          <p:nvPr/>
+        </p:nvSpPr>
+        <p:spPr>
+          <a:xfrm>
+            <a:off x="1554480" y="3703320"/>
             <a:ext cx="10058400" cy="365760"/>
           </a:xfrm>
           <a:prstGeom prst="rect">
@@ -5804,7 +6132,7 @@
                 <a:ea typeface="Calibri" pitchFamily="34" charset="-122"/>
                 <a:cs typeface="Calibri" pitchFamily="34" charset="-120"/>
               </a:rPr>
-              <a:t>Schema-validated; agents can rely on shape, not vibes.</a:t>
+              <a:t>Cross-references between specs and to source code, validated.</a:t>
             </a:r>
             <a:endParaRPr lang="en-US" sz="1300" dirty="0"/>
           </a:p>
@@ -5812,13 +6140,13 @@
       </p:sp>
       <p:sp>
         <p:nvSpPr>
-          <p:cNvPr id="8" name="Shape 6"/>
-          <p:cNvSpPr/>
-          <p:nvPr/>
-        </p:nvSpPr>
-        <p:spPr>
-          <a:xfrm>
-            <a:off x="640080" y="2606040"/>
+          <p:cNvPr id="16" name="Shape 14"/>
+          <p:cNvSpPr/>
+          <p:nvPr/>
+        </p:nvSpPr>
+        <p:spPr>
+          <a:xfrm>
+            <a:off x="640080" y="4343400"/>
             <a:ext cx="640080" cy="640080"/>
           </a:xfrm>
           <a:prstGeom prst="ellipse">
@@ -5839,13 +6167,13 @@
       </p:sp>
       <p:sp>
         <p:nvSpPr>
-          <p:cNvPr id="9" name="Text 7"/>
-          <p:cNvSpPr/>
-          <p:nvPr/>
-        </p:nvSpPr>
-        <p:spPr>
-          <a:xfrm>
-            <a:off x="640080" y="2606040"/>
+          <p:cNvPr id="17" name="Text 15"/>
+          <p:cNvSpPr/>
+          <p:nvPr/>
+        </p:nvSpPr>
+        <p:spPr>
+          <a:xfrm>
+            <a:off x="640080" y="4343400"/>
             <a:ext cx="640080" cy="640080"/>
           </a:xfrm>
           <a:prstGeom prst="rect">
@@ -5870,7 +6198,7 @@
                 <a:ea typeface="Georgia" pitchFamily="34" charset="-122"/>
                 <a:cs typeface="Georgia" pitchFamily="34" charset="-120"/>
               </a:rPr>
-              <a:t>2</a:t>
+              <a:t>4</a:t>
             </a:r>
             <a:endParaRPr lang="en-US" sz="2400" dirty="0"/>
           </a:p>
@@ -5878,13 +6206,13 @@
       </p:sp>
       <p:sp>
         <p:nvSpPr>
-          <p:cNvPr id="10" name="Text 8"/>
-          <p:cNvSpPr/>
-          <p:nvPr/>
-        </p:nvSpPr>
-        <p:spPr>
-          <a:xfrm>
-            <a:off x="1554480" y="2606040"/>
+          <p:cNvPr id="18" name="Text 16"/>
+          <p:cNvSpPr/>
+          <p:nvPr/>
+        </p:nvSpPr>
+        <p:spPr>
+          <a:xfrm>
+            <a:off x="1554480" y="4343400"/>
             <a:ext cx="2743200" cy="365760"/>
           </a:xfrm>
           <a:prstGeom prst="rect">
@@ -5904,446 +6232,162 @@
               <a:rPr lang="en-US" sz="1800" b="1" dirty="0">
                 <a:solidFill>
                   <a:srgbClr val="1A1A1A"/>
+                </a:solidFill>
+                <a:latin typeface="Comfortaa" pitchFamily="2" charset="0"/>
+                <a:ea typeface="Georgia" pitchFamily="34" charset="-122"/>
+                <a:cs typeface="Georgia" pitchFamily="34" charset="-120"/>
+              </a:rPr>
+              <a:t>Versionable</a:t>
+            </a:r>
+            <a:endParaRPr lang="en-US" sz="1800" dirty="0">
+              <a:latin typeface="Comfortaa Medium" pitchFamily="2" charset="0"/>
+            </a:endParaRPr>
+          </a:p>
+        </p:txBody>
+      </p:sp>
+      <p:sp>
+        <p:nvSpPr>
+          <p:cNvPr id="19" name="Text 17"/>
+          <p:cNvSpPr/>
+          <p:nvPr/>
+        </p:nvSpPr>
+        <p:spPr>
+          <a:xfrm>
+            <a:off x="1554480" y="4572000"/>
+            <a:ext cx="10058400" cy="365760"/>
+          </a:xfrm>
+          <a:prstGeom prst="rect">
+            <a:avLst/>
+          </a:prstGeom>
+          <a:noFill/>
+          <a:ln/>
+        </p:spPr>
+        <p:txBody>
+          <a:bodyPr wrap="square" lIns="0" tIns="0" rIns="0" bIns="0" rtlCol="0" anchor="ctr"/>
+          <a:lstStyle/>
+          <a:p>
+            <a:pPr marL="0" indent="0">
+              <a:buNone/>
+            </a:pPr>
+            <a:r>
+              <a:rPr lang="en-US" sz="1300" dirty="0">
+                <a:solidFill>
+                  <a:srgbClr val="6B6B6B"/>
+                </a:solidFill>
+                <a:latin typeface="Calibri" pitchFamily="34" charset="0"/>
+                <a:ea typeface="Calibri" pitchFamily="34" charset="-122"/>
+                <a:cs typeface="Calibri" pitchFamily="34" charset="-120"/>
+              </a:rPr>
+              <a:t>Git-native. Specs and commits cite each other, both directions.</a:t>
+            </a:r>
+            <a:endParaRPr lang="en-US" sz="1300" dirty="0"/>
+          </a:p>
+        </p:txBody>
+      </p:sp>
+      <p:sp>
+        <p:nvSpPr>
+          <p:cNvPr id="20" name="Shape 18"/>
+          <p:cNvSpPr/>
+          <p:nvPr/>
+        </p:nvSpPr>
+        <p:spPr>
+          <a:xfrm>
+            <a:off x="640080" y="5212080"/>
+            <a:ext cx="640080" cy="640080"/>
+          </a:xfrm>
+          <a:prstGeom prst="ellipse">
+            <a:avLst/>
+          </a:prstGeom>
+          <a:solidFill>
+            <a:srgbClr val="028090"/>
+          </a:solidFill>
+          <a:ln/>
+        </p:spPr>
+        <p:txBody>
+          <a:bodyPr/>
+          <a:lstStyle/>
+          <a:p>
+            <a:endParaRPr lang="en-US"/>
+          </a:p>
+        </p:txBody>
+      </p:sp>
+      <p:sp>
+        <p:nvSpPr>
+          <p:cNvPr id="21" name="Text 19"/>
+          <p:cNvSpPr/>
+          <p:nvPr/>
+        </p:nvSpPr>
+        <p:spPr>
+          <a:xfrm>
+            <a:off x="640080" y="5212080"/>
+            <a:ext cx="640080" cy="640080"/>
+          </a:xfrm>
+          <a:prstGeom prst="rect">
+            <a:avLst/>
+          </a:prstGeom>
+          <a:noFill/>
+          <a:ln/>
+        </p:spPr>
+        <p:txBody>
+          <a:bodyPr wrap="square" lIns="0" tIns="0" rIns="0" bIns="0" rtlCol="0" anchor="ctr"/>
+          <a:lstStyle/>
+          <a:p>
+            <a:pPr marL="0" indent="0" algn="ctr">
+              <a:buNone/>
+            </a:pPr>
+            <a:r>
+              <a:rPr lang="en-US" sz="2400" b="1" dirty="0">
+                <a:solidFill>
+                  <a:srgbClr val="FFFFFF"/>
                 </a:solidFill>
                 <a:latin typeface="Georgia" pitchFamily="34" charset="0"/>
                 <a:ea typeface="Georgia" pitchFamily="34" charset="-122"/>
                 <a:cs typeface="Georgia" pitchFamily="34" charset="-120"/>
               </a:rPr>
-              <a:t>Readable</a:t>
-            </a:r>
-            <a:endParaRPr lang="en-US" sz="1800" dirty="0"/>
-          </a:p>
-        </p:txBody>
-      </p:sp>
-      <p:sp>
-        <p:nvSpPr>
-          <p:cNvPr id="11" name="Text 9"/>
-          <p:cNvSpPr/>
-          <p:nvPr/>
-        </p:nvSpPr>
-        <p:spPr>
-          <a:xfrm>
-            <a:off x="1554480" y="2971800"/>
-            <a:ext cx="10058400" cy="365760"/>
-          </a:xfrm>
-          <a:prstGeom prst="rect">
-            <a:avLst/>
-          </a:prstGeom>
-          <a:noFill/>
-          <a:ln/>
-        </p:spPr>
-        <p:txBody>
-          <a:bodyPr wrap="square" lIns="0" tIns="0" rIns="0" bIns="0" rtlCol="0" anchor="ctr"/>
-          <a:lstStyle/>
-          <a:p>
-            <a:pPr marL="0" indent="0">
-              <a:buNone/>
-            </a:pPr>
-            <a:r>
-              <a:rPr lang="en-US" sz="1300" dirty="0">
-                <a:solidFill>
-                  <a:srgbClr val="6B6B6B"/>
-                </a:solidFill>
-                <a:latin typeface="Calibri" pitchFamily="34" charset="0"/>
-                <a:ea typeface="Calibri" pitchFamily="34" charset="-122"/>
-                <a:cs typeface="Calibri" pitchFamily="34" charset="-120"/>
-              </a:rPr>
-              <a:t>Canonical form is Markdown. Reviewable in a PR like any other text.</a:t>
-            </a:r>
-            <a:endParaRPr lang="en-US" sz="1300" dirty="0"/>
-          </a:p>
-        </p:txBody>
-      </p:sp>
-      <p:sp>
-        <p:nvSpPr>
-          <p:cNvPr id="12" name="Shape 10"/>
-          <p:cNvSpPr/>
-          <p:nvPr/>
-        </p:nvSpPr>
-        <p:spPr>
-          <a:xfrm>
-            <a:off x="640080" y="3474720"/>
-            <a:ext cx="640080" cy="640080"/>
-          </a:xfrm>
-          <a:prstGeom prst="ellipse">
-            <a:avLst/>
-          </a:prstGeom>
-          <a:solidFill>
-            <a:srgbClr val="028090"/>
-          </a:solidFill>
-          <a:ln/>
-        </p:spPr>
-        <p:txBody>
-          <a:bodyPr/>
-          <a:lstStyle/>
-          <a:p>
-            <a:endParaRPr lang="en-US"/>
-          </a:p>
-        </p:txBody>
-      </p:sp>
-      <p:sp>
-        <p:nvSpPr>
-          <p:cNvPr id="13" name="Text 11"/>
-          <p:cNvSpPr/>
-          <p:nvPr/>
-        </p:nvSpPr>
-        <p:spPr>
-          <a:xfrm>
-            <a:off x="640080" y="3474720"/>
-            <a:ext cx="640080" cy="640080"/>
-          </a:xfrm>
-          <a:prstGeom prst="rect">
-            <a:avLst/>
-          </a:prstGeom>
-          <a:noFill/>
-          <a:ln/>
-        </p:spPr>
-        <p:txBody>
-          <a:bodyPr wrap="square" lIns="0" tIns="0" rIns="0" bIns="0" rtlCol="0" anchor="ctr"/>
-          <a:lstStyle/>
-          <a:p>
-            <a:pPr marL="0" indent="0" algn="ctr">
-              <a:buNone/>
-            </a:pPr>
-            <a:r>
-              <a:rPr lang="en-US" sz="2400" b="1" dirty="0">
-                <a:solidFill>
-                  <a:srgbClr val="FFFFFF"/>
-                </a:solidFill>
-                <a:latin typeface="Georgia" pitchFamily="34" charset="0"/>
+              <a:t>5</a:t>
+            </a:r>
+            <a:endParaRPr lang="en-US" sz="2400" dirty="0"/>
+          </a:p>
+        </p:txBody>
+      </p:sp>
+      <p:sp>
+        <p:nvSpPr>
+          <p:cNvPr id="22" name="Text 20"/>
+          <p:cNvSpPr/>
+          <p:nvPr/>
+        </p:nvSpPr>
+        <p:spPr>
+          <a:xfrm>
+            <a:off x="1554480" y="5212080"/>
+            <a:ext cx="2743200" cy="365760"/>
+          </a:xfrm>
+          <a:prstGeom prst="rect">
+            <a:avLst/>
+          </a:prstGeom>
+          <a:noFill/>
+          <a:ln/>
+        </p:spPr>
+        <p:txBody>
+          <a:bodyPr wrap="square" lIns="0" tIns="0" rIns="0" bIns="0" rtlCol="0" anchor="ctr"/>
+          <a:lstStyle/>
+          <a:p>
+            <a:pPr marL="0" indent="0">
+              <a:buNone/>
+            </a:pPr>
+            <a:r>
+              <a:rPr lang="en-US" sz="1800" b="1" dirty="0">
+                <a:solidFill>
+                  <a:srgbClr val="1A1A1A"/>
+                </a:solidFill>
+                <a:latin typeface="Comfortaa" pitchFamily="2" charset="0"/>
                 <a:ea typeface="Georgia" pitchFamily="34" charset="-122"/>
                 <a:cs typeface="Georgia" pitchFamily="34" charset="-120"/>
               </a:rPr>
-              <a:t>3</a:t>
-            </a:r>
-            <a:endParaRPr lang="en-US" sz="2400" dirty="0"/>
-          </a:p>
-        </p:txBody>
-      </p:sp>
-      <p:sp>
-        <p:nvSpPr>
-          <p:cNvPr id="14" name="Text 12"/>
-          <p:cNvSpPr/>
-          <p:nvPr/>
-        </p:nvSpPr>
-        <p:spPr>
-          <a:xfrm>
-            <a:off x="1554480" y="3474720"/>
-            <a:ext cx="2743200" cy="365760"/>
-          </a:xfrm>
-          <a:prstGeom prst="rect">
-            <a:avLst/>
-          </a:prstGeom>
-          <a:noFill/>
-          <a:ln/>
-        </p:spPr>
-        <p:txBody>
-          <a:bodyPr wrap="square" lIns="0" tIns="0" rIns="0" bIns="0" rtlCol="0" anchor="ctr"/>
-          <a:lstStyle/>
-          <a:p>
-            <a:pPr marL="0" indent="0">
-              <a:buNone/>
-            </a:pPr>
-            <a:r>
-              <a:rPr lang="en-US" sz="1800" b="1" dirty="0">
-                <a:solidFill>
-                  <a:srgbClr val="1A1A1A"/>
-                </a:solidFill>
-                <a:latin typeface="Georgia" pitchFamily="34" charset="0"/>
-                <a:ea typeface="Georgia" pitchFamily="34" charset="-122"/>
-                <a:cs typeface="Georgia" pitchFamily="34" charset="-120"/>
-              </a:rPr>
-              <a:t>Linked</a:t>
-            </a:r>
-            <a:endParaRPr lang="en-US" sz="1800" dirty="0"/>
-          </a:p>
-        </p:txBody>
-      </p:sp>
-      <p:sp>
-        <p:nvSpPr>
-          <p:cNvPr id="15" name="Text 13"/>
-          <p:cNvSpPr/>
-          <p:nvPr/>
-        </p:nvSpPr>
-        <p:spPr>
-          <a:xfrm>
-            <a:off x="1554480" y="3840480"/>
-            <a:ext cx="10058400" cy="365760"/>
-          </a:xfrm>
-          <a:prstGeom prst="rect">
-            <a:avLst/>
-          </a:prstGeom>
-          <a:noFill/>
-          <a:ln/>
-        </p:spPr>
-        <p:txBody>
-          <a:bodyPr wrap="square" lIns="0" tIns="0" rIns="0" bIns="0" rtlCol="0" anchor="ctr"/>
-          <a:lstStyle/>
-          <a:p>
-            <a:pPr marL="0" indent="0">
-              <a:buNone/>
-            </a:pPr>
-            <a:r>
-              <a:rPr lang="en-US" sz="1300" dirty="0">
-                <a:solidFill>
-                  <a:srgbClr val="6B6B6B"/>
-                </a:solidFill>
-                <a:latin typeface="Calibri" pitchFamily="34" charset="0"/>
-                <a:ea typeface="Calibri" pitchFamily="34" charset="-122"/>
-                <a:cs typeface="Calibri" pitchFamily="34" charset="-120"/>
-              </a:rPr>
-              <a:t>Cross-references between specs and to source code, validated.</a:t>
-            </a:r>
-            <a:endParaRPr lang="en-US" sz="1300" dirty="0"/>
-          </a:p>
-        </p:txBody>
-      </p:sp>
-      <p:sp>
-        <p:nvSpPr>
-          <p:cNvPr id="16" name="Shape 14"/>
-          <p:cNvSpPr/>
-          <p:nvPr/>
-        </p:nvSpPr>
-        <p:spPr>
-          <a:xfrm>
-            <a:off x="640080" y="4343400"/>
-            <a:ext cx="640080" cy="640080"/>
-          </a:xfrm>
-          <a:prstGeom prst="ellipse">
-            <a:avLst/>
-          </a:prstGeom>
-          <a:solidFill>
-            <a:srgbClr val="028090"/>
-          </a:solidFill>
-          <a:ln/>
-        </p:spPr>
-        <p:txBody>
-          <a:bodyPr/>
-          <a:lstStyle/>
-          <a:p>
-            <a:endParaRPr lang="en-US"/>
-          </a:p>
-        </p:txBody>
-      </p:sp>
-      <p:sp>
-        <p:nvSpPr>
-          <p:cNvPr id="17" name="Text 15"/>
-          <p:cNvSpPr/>
-          <p:nvPr/>
-        </p:nvSpPr>
-        <p:spPr>
-          <a:xfrm>
-            <a:off x="640080" y="4343400"/>
-            <a:ext cx="640080" cy="640080"/>
-          </a:xfrm>
-          <a:prstGeom prst="rect">
-            <a:avLst/>
-          </a:prstGeom>
-          <a:noFill/>
-          <a:ln/>
-        </p:spPr>
-        <p:txBody>
-          <a:bodyPr wrap="square" lIns="0" tIns="0" rIns="0" bIns="0" rtlCol="0" anchor="ctr"/>
-          <a:lstStyle/>
-          <a:p>
-            <a:pPr marL="0" indent="0" algn="ctr">
-              <a:buNone/>
-            </a:pPr>
-            <a:r>
-              <a:rPr lang="en-US" sz="2400" b="1" dirty="0">
-                <a:solidFill>
-                  <a:srgbClr val="FFFFFF"/>
-                </a:solidFill>
-                <a:latin typeface="Georgia" pitchFamily="34" charset="0"/>
-                <a:ea typeface="Georgia" pitchFamily="34" charset="-122"/>
-                <a:cs typeface="Georgia" pitchFamily="34" charset="-120"/>
-              </a:rPr>
-              <a:t>4</a:t>
-            </a:r>
-            <a:endParaRPr lang="en-US" sz="2400" dirty="0"/>
-          </a:p>
-        </p:txBody>
-      </p:sp>
-      <p:sp>
-        <p:nvSpPr>
-          <p:cNvPr id="18" name="Text 16"/>
-          <p:cNvSpPr/>
-          <p:nvPr/>
-        </p:nvSpPr>
-        <p:spPr>
-          <a:xfrm>
-            <a:off x="1554480" y="4343400"/>
-            <a:ext cx="2743200" cy="365760"/>
-          </a:xfrm>
-          <a:prstGeom prst="rect">
-            <a:avLst/>
-          </a:prstGeom>
-          <a:noFill/>
-          <a:ln/>
-        </p:spPr>
-        <p:txBody>
-          <a:bodyPr wrap="square" lIns="0" tIns="0" rIns="0" bIns="0" rtlCol="0" anchor="ctr"/>
-          <a:lstStyle/>
-          <a:p>
-            <a:pPr marL="0" indent="0">
-              <a:buNone/>
-            </a:pPr>
-            <a:r>
-              <a:rPr lang="en-US" sz="1800" b="1" dirty="0">
-                <a:solidFill>
-                  <a:srgbClr val="1A1A1A"/>
-                </a:solidFill>
-                <a:latin typeface="Georgia" pitchFamily="34" charset="0"/>
-                <a:ea typeface="Georgia" pitchFamily="34" charset="-122"/>
-                <a:cs typeface="Georgia" pitchFamily="34" charset="-120"/>
-              </a:rPr>
-              <a:t>Versionable</a:t>
-            </a:r>
-            <a:endParaRPr lang="en-US" sz="1800" dirty="0"/>
-          </a:p>
-        </p:txBody>
-      </p:sp>
-      <p:sp>
-        <p:nvSpPr>
-          <p:cNvPr id="19" name="Text 17"/>
-          <p:cNvSpPr/>
-          <p:nvPr/>
-        </p:nvSpPr>
-        <p:spPr>
-          <a:xfrm>
-            <a:off x="1554480" y="4709160"/>
-            <a:ext cx="10058400" cy="365760"/>
-          </a:xfrm>
-          <a:prstGeom prst="rect">
-            <a:avLst/>
-          </a:prstGeom>
-          <a:noFill/>
-          <a:ln/>
-        </p:spPr>
-        <p:txBody>
-          <a:bodyPr wrap="square" lIns="0" tIns="0" rIns="0" bIns="0" rtlCol="0" anchor="ctr"/>
-          <a:lstStyle/>
-          <a:p>
-            <a:pPr marL="0" indent="0">
-              <a:buNone/>
-            </a:pPr>
-            <a:r>
-              <a:rPr lang="en-US" sz="1300" dirty="0">
-                <a:solidFill>
-                  <a:srgbClr val="6B6B6B"/>
-                </a:solidFill>
-                <a:latin typeface="Calibri" pitchFamily="34" charset="0"/>
-                <a:ea typeface="Calibri" pitchFamily="34" charset="-122"/>
-                <a:cs typeface="Calibri" pitchFamily="34" charset="-120"/>
-              </a:rPr>
-              <a:t>Git-native. Specs and commits cite each other, both directions.</a:t>
-            </a:r>
-            <a:endParaRPr lang="en-US" sz="1300" dirty="0"/>
-          </a:p>
-        </p:txBody>
-      </p:sp>
-      <p:sp>
-        <p:nvSpPr>
-          <p:cNvPr id="20" name="Shape 18"/>
-          <p:cNvSpPr/>
-          <p:nvPr/>
-        </p:nvSpPr>
-        <p:spPr>
-          <a:xfrm>
-            <a:off x="640080" y="5212080"/>
-            <a:ext cx="640080" cy="640080"/>
-          </a:xfrm>
-          <a:prstGeom prst="ellipse">
-            <a:avLst/>
-          </a:prstGeom>
-          <a:solidFill>
-            <a:srgbClr val="028090"/>
-          </a:solidFill>
-          <a:ln/>
-        </p:spPr>
-        <p:txBody>
-          <a:bodyPr/>
-          <a:lstStyle/>
-          <a:p>
-            <a:endParaRPr lang="en-US"/>
-          </a:p>
-        </p:txBody>
-      </p:sp>
-      <p:sp>
-        <p:nvSpPr>
-          <p:cNvPr id="21" name="Text 19"/>
-          <p:cNvSpPr/>
-          <p:nvPr/>
-        </p:nvSpPr>
-        <p:spPr>
-          <a:xfrm>
-            <a:off x="640080" y="5212080"/>
-            <a:ext cx="640080" cy="640080"/>
-          </a:xfrm>
-          <a:prstGeom prst="rect">
-            <a:avLst/>
-          </a:prstGeom>
-          <a:noFill/>
-          <a:ln/>
-        </p:spPr>
-        <p:txBody>
-          <a:bodyPr wrap="square" lIns="0" tIns="0" rIns="0" bIns="0" rtlCol="0" anchor="ctr"/>
-          <a:lstStyle/>
-          <a:p>
-            <a:pPr marL="0" indent="0" algn="ctr">
-              <a:buNone/>
-            </a:pPr>
-            <a:r>
-              <a:rPr lang="en-US" sz="2400" b="1" dirty="0">
-                <a:solidFill>
-                  <a:srgbClr val="FFFFFF"/>
-                </a:solidFill>
-                <a:latin typeface="Georgia" pitchFamily="34" charset="0"/>
-                <a:ea typeface="Georgia" pitchFamily="34" charset="-122"/>
-                <a:cs typeface="Georgia" pitchFamily="34" charset="-120"/>
-              </a:rPr>
-              <a:t>5</a:t>
-            </a:r>
-            <a:endParaRPr lang="en-US" sz="2400" dirty="0"/>
-          </a:p>
-        </p:txBody>
-      </p:sp>
-      <p:sp>
-        <p:nvSpPr>
-          <p:cNvPr id="22" name="Text 20"/>
-          <p:cNvSpPr/>
-          <p:nvPr/>
-        </p:nvSpPr>
-        <p:spPr>
-          <a:xfrm>
-            <a:off x="1554480" y="5212080"/>
-            <a:ext cx="2743200" cy="365760"/>
-          </a:xfrm>
-          <a:prstGeom prst="rect">
-            <a:avLst/>
-          </a:prstGeom>
-          <a:noFill/>
-          <a:ln/>
-        </p:spPr>
-        <p:txBody>
-          <a:bodyPr wrap="square" lIns="0" tIns="0" rIns="0" bIns="0" rtlCol="0" anchor="ctr"/>
-          <a:lstStyle/>
-          <a:p>
-            <a:pPr marL="0" indent="0">
-              <a:buNone/>
-            </a:pPr>
-            <a:r>
-              <a:rPr lang="en-US" sz="1800" b="1" dirty="0">
-                <a:solidFill>
-                  <a:srgbClr val="1A1A1A"/>
-                </a:solidFill>
-                <a:latin typeface="Georgia" pitchFamily="34" charset="0"/>
-                <a:ea typeface="Georgia" pitchFamily="34" charset="-122"/>
-                <a:cs typeface="Georgia" pitchFamily="34" charset="-120"/>
-              </a:rPr>
               <a:t>Translatable</a:t>
             </a:r>
-            <a:endParaRPr lang="en-US" sz="1800" dirty="0"/>
+            <a:endParaRPr lang="en-US" sz="1800" dirty="0">
+              <a:latin typeface="Comfortaa Medium" pitchFamily="2" charset="0"/>
+            </a:endParaRPr>
           </a:p>
         </p:txBody>
       </p:sp>
@@ -6355,7 +6399,7 @@
         </p:nvSpPr>
         <p:spPr>
           <a:xfrm>
-            <a:off x="1554480" y="5577840"/>
+            <a:off x="1554480" y="5440680"/>
             <a:ext cx="10058400" cy="365760"/>
           </a:xfrm>
           <a:prstGeom prst="rect">
@@ -6526,13 +6570,15 @@
                 <a:solidFill>
                   <a:srgbClr val="1A1A1A"/>
                 </a:solidFill>
-                <a:latin typeface="Georgia" pitchFamily="34" charset="0"/>
+                <a:latin typeface="Comfortaa" pitchFamily="2" charset="0"/>
                 <a:ea typeface="Georgia" pitchFamily="34" charset="-122"/>
                 <a:cs typeface="Georgia" pitchFamily="34" charset="-120"/>
               </a:rPr>
               <a:t>Anatomy of a spec file</a:t>
             </a:r>
-            <a:endParaRPr lang="en-US" sz="3000" dirty="0"/>
+            <a:endParaRPr lang="en-US" sz="3000" dirty="0">
+              <a:latin typeface="Comfortaa Medium" pitchFamily="2" charset="0"/>
+            </a:endParaRPr>
           </a:p>
         </p:txBody>
       </p:sp>
@@ -7020,13 +7066,15 @@
                 <a:solidFill>
                   <a:srgbClr val="1A1A1A"/>
                 </a:solidFill>
-                <a:latin typeface="Georgia" pitchFamily="34" charset="0"/>
+                <a:latin typeface="Comfortaa" pitchFamily="2" charset="0"/>
                 <a:ea typeface="Georgia" pitchFamily="34" charset="-122"/>
                 <a:cs typeface="Georgia" pitchFamily="34" charset="-120"/>
               </a:rPr>
               <a:t>Frontmatter</a:t>
             </a:r>
-            <a:endParaRPr lang="en-US" sz="1400" dirty="0"/>
+            <a:endParaRPr lang="en-US" sz="1400" dirty="0">
+              <a:latin typeface="Comfortaa Medium" pitchFamily="2" charset="0"/>
+            </a:endParaRPr>
           </a:p>
         </p:txBody>
       </p:sp>
@@ -7125,13 +7173,15 @@
                 <a:solidFill>
                   <a:srgbClr val="1A1A1A"/>
                 </a:solidFill>
-                <a:latin typeface="Georgia" pitchFamily="34" charset="0"/>
+                <a:latin typeface="Comfortaa" pitchFamily="2" charset="0"/>
                 <a:ea typeface="Georgia" pitchFamily="34" charset="-122"/>
                 <a:cs typeface="Georgia" pitchFamily="34" charset="-120"/>
               </a:rPr>
               <a:t>References</a:t>
             </a:r>
-            <a:endParaRPr lang="en-US" sz="1400" dirty="0"/>
+            <a:endParaRPr lang="en-US" sz="1400" dirty="0">
+              <a:latin typeface="Comfortaa Medium" pitchFamily="2" charset="0"/>
+            </a:endParaRPr>
           </a:p>
         </p:txBody>
       </p:sp>
@@ -7230,13 +7280,15 @@
                 <a:solidFill>
                   <a:srgbClr val="1A1A1A"/>
                 </a:solidFill>
-                <a:latin typeface="Georgia" pitchFamily="34" charset="0"/>
+                <a:latin typeface="Comfortaa" pitchFamily="2" charset="0"/>
                 <a:ea typeface="Georgia" pitchFamily="34" charset="-122"/>
                 <a:cs typeface="Georgia" pitchFamily="34" charset="-120"/>
               </a:rPr>
               <a:t>Typed blocks</a:t>
             </a:r>
-            <a:endParaRPr lang="en-US" sz="1400" dirty="0"/>
+            <a:endParaRPr lang="en-US" sz="1400" dirty="0">
+              <a:latin typeface="Comfortaa Medium" pitchFamily="2" charset="0"/>
+            </a:endParaRPr>
           </a:p>
         </p:txBody>
       </p:sp>
@@ -7335,13 +7387,15 @@
                 <a:solidFill>
                   <a:srgbClr val="1A1A1A"/>
                 </a:solidFill>
-                <a:latin typeface="Georgia" pitchFamily="34" charset="0"/>
+                <a:latin typeface="Comfortaa" pitchFamily="2" charset="0"/>
                 <a:ea typeface="Georgia" pitchFamily="34" charset="-122"/>
                 <a:cs typeface="Georgia" pitchFamily="34" charset="-120"/>
               </a:rPr>
               <a:t>Clauses</a:t>
             </a:r>
-            <a:endParaRPr lang="en-US" sz="1400" dirty="0"/>
+            <a:endParaRPr lang="en-US" sz="1400" dirty="0">
+              <a:latin typeface="Comfortaa Medium" pitchFamily="2" charset="0"/>
+            </a:endParaRPr>
           </a:p>
         </p:txBody>
       </p:sp>
@@ -7524,13 +7578,15 @@
                 <a:solidFill>
                   <a:srgbClr val="1A1A1A"/>
                 </a:solidFill>
-                <a:latin typeface="Georgia" pitchFamily="34" charset="0"/>
+                <a:latin typeface="Comfortaa" pitchFamily="2" charset="0"/>
                 <a:ea typeface="Georgia" pitchFamily="34" charset="-122"/>
                 <a:cs typeface="Georgia" pitchFamily="34" charset="-120"/>
               </a:rPr>
               <a:t>Hierarchy: clause-level refinement</a:t>
             </a:r>
-            <a:endParaRPr lang="en-US" sz="3000" dirty="0"/>
+            <a:endParaRPr lang="en-US" sz="3000" dirty="0">
+              <a:latin typeface="Comfortaa Medium" pitchFamily="2" charset="0"/>
+            </a:endParaRPr>
           </a:p>
         </p:txBody>
       </p:sp>
@@ -8559,13 +8615,15 @@
                 <a:solidFill>
                   <a:srgbClr val="1A1A1A"/>
                 </a:solidFill>
-                <a:latin typeface="Georgia" pitchFamily="34" charset="0"/>
+                <a:latin typeface="Comfortaa" pitchFamily="2" charset="0"/>
                 <a:ea typeface="Georgia" pitchFamily="34" charset="-122"/>
                 <a:cs typeface="Georgia" pitchFamily="34" charset="-120"/>
               </a:rPr>
               <a:t>Cross-references, validated</a:t>
             </a:r>
-            <a:endParaRPr lang="en-US" sz="3000" dirty="0"/>
+            <a:endParaRPr lang="en-US" sz="3000" dirty="0">
+              <a:latin typeface="Comfortaa Medium" pitchFamily="2" charset="0"/>
+            </a:endParaRPr>
           </a:p>
         </p:txBody>
       </p:sp>
@@ -8825,13 +8883,15 @@
                 <a:solidFill>
                   <a:srgbClr val="1A1A1A"/>
                 </a:solidFill>
-                <a:latin typeface="Georgia" pitchFamily="34" charset="0"/>
+                <a:latin typeface="Comfortaa" pitchFamily="2" charset="0"/>
                 <a:ea typeface="Georgia" pitchFamily="34" charset="-122"/>
                 <a:cs typeface="Georgia" pitchFamily="34" charset="-120"/>
               </a:rPr>
               <a:t>Stable IDs</a:t>
             </a:r>
-            <a:endParaRPr lang="en-US" sz="1700" dirty="0"/>
+            <a:endParaRPr lang="en-US" sz="1700" dirty="0">
+              <a:latin typeface="Comfortaa Medium" pitchFamily="2" charset="0"/>
+            </a:endParaRPr>
           </a:p>
         </p:txBody>
       </p:sp>
@@ -8962,13 +9022,15 @@
                 <a:solidFill>
                   <a:srgbClr val="1A1A1A"/>
                 </a:solidFill>
-                <a:latin typeface="Georgia" pitchFamily="34" charset="0"/>
+                <a:latin typeface="Comfortaa" pitchFamily="2" charset="0"/>
                 <a:ea typeface="Georgia" pitchFamily="34" charset="-122"/>
                 <a:cs typeface="Georgia" pitchFamily="34" charset="-120"/>
               </a:rPr>
               <a:t>Typed targets</a:t>
             </a:r>
-            <a:endParaRPr lang="en-US" sz="1700" dirty="0"/>
+            <a:endParaRPr lang="en-US" sz="1700" dirty="0">
+              <a:latin typeface="Comfortaa Medium" pitchFamily="2" charset="0"/>
+            </a:endParaRPr>
           </a:p>
         </p:txBody>
       </p:sp>
@@ -9099,13 +9161,15 @@
                 <a:solidFill>
                   <a:srgbClr val="1A1A1A"/>
                 </a:solidFill>
-                <a:latin typeface="Georgia" pitchFamily="34" charset="0"/>
+                <a:latin typeface="Comfortaa" pitchFamily="2" charset="0"/>
                 <a:ea typeface="Georgia" pitchFamily="34" charset="-122"/>
                 <a:cs typeface="Georgia" pitchFamily="34" charset="-120"/>
               </a:rPr>
               <a:t>Linted on commit</a:t>
             </a:r>
-            <a:endParaRPr lang="en-US" sz="1700" dirty="0"/>
+            <a:endParaRPr lang="en-US" sz="1700" dirty="0">
+              <a:latin typeface="Comfortaa Medium" pitchFamily="2" charset="0"/>
+            </a:endParaRPr>
           </a:p>
         </p:txBody>
       </p:sp>
@@ -9288,13 +9352,15 @@
                 <a:solidFill>
                   <a:srgbClr val="1A1A1A"/>
                 </a:solidFill>
-                <a:latin typeface="Georgia" pitchFamily="34" charset="0"/>
+                <a:latin typeface="Comfortaa" pitchFamily="2" charset="0"/>
                 <a:ea typeface="Georgia" pitchFamily="34" charset="-122"/>
                 <a:cs typeface="Georgia" pitchFamily="34" charset="-120"/>
               </a:rPr>
               <a:t>Git integration: bidirectional</a:t>
             </a:r>
-            <a:endParaRPr lang="en-US" sz="3000" dirty="0"/>
+            <a:endParaRPr lang="en-US" sz="3000" dirty="0">
+              <a:latin typeface="Comfortaa Medium" pitchFamily="2" charset="0"/>
+            </a:endParaRPr>
           </a:p>
         </p:txBody>
       </p:sp>
@@ -10017,13 +10083,15 @@
                 <a:solidFill>
                   <a:srgbClr val="1A1A1A"/>
                 </a:solidFill>
-                <a:latin typeface="Georgia" pitchFamily="34" charset="0"/>
+                <a:latin typeface="Comfortaa" pitchFamily="2" charset="0"/>
                 <a:ea typeface="Georgia" pitchFamily="34" charset="-122"/>
                 <a:cs typeface="Georgia" pitchFamily="34" charset="-120"/>
               </a:rPr>
               <a:t>Transmutation: one source, two targets</a:t>
             </a:r>
-            <a:endParaRPr lang="en-US" sz="3000" dirty="0"/>
+            <a:endParaRPr lang="en-US" sz="3000" dirty="0">
+              <a:latin typeface="Comfortaa Medium" pitchFamily="2" charset="0"/>
+            </a:endParaRPr>
           </a:p>
         </p:txBody>
       </p:sp>
@@ -10732,13 +10800,15 @@
                 <a:solidFill>
                   <a:srgbClr val="1A1A1A"/>
                 </a:solidFill>
-                <a:latin typeface="Georgia" pitchFamily="34" charset="0"/>
+                <a:latin typeface="Comfortaa" pitchFamily="2" charset="0"/>
                 <a:ea typeface="Georgia" pitchFamily="34" charset="-122"/>
                 <a:cs typeface="Georgia" pitchFamily="34" charset="-120"/>
               </a:rPr>
               <a:t>Tooling: one CLI, fixed surface</a:t>
             </a:r>
-            <a:endParaRPr lang="en-US" sz="3000" dirty="0"/>
+            <a:endParaRPr lang="en-US" sz="3000" dirty="0">
+              <a:latin typeface="Comfortaa Medium" pitchFamily="2" charset="0"/>
+            </a:endParaRPr>
           </a:p>
         </p:txBody>
       </p:sp>
@@ -11622,13 +11692,15 @@
                 <a:solidFill>
                   <a:srgbClr val="1A1A1A"/>
                 </a:solidFill>
-                <a:latin typeface="Georgia" pitchFamily="34" charset="0"/>
+                <a:latin typeface="Comfortaa" pitchFamily="2" charset="0"/>
                 <a:ea typeface="Georgia" pitchFamily="34" charset="-122"/>
                 <a:cs typeface="Georgia" pitchFamily="34" charset="-120"/>
               </a:rPr>
               <a:t>Linter findings have stable codes</a:t>
             </a:r>
-            <a:endParaRPr lang="en-US" sz="1400" dirty="0"/>
+            <a:endParaRPr lang="en-US" sz="1400" dirty="0">
+              <a:latin typeface="Comfortaa Medium" pitchFamily="2" charset="0"/>
+            </a:endParaRPr>
           </a:p>
         </p:txBody>
       </p:sp>

</xml_diff>